<commit_message>
Companions: Volume II decks with the In Practice cases
The sixteen Volume II decks gain an In Practice slide for the chapter's
two-page case from a real organization (the decision, the method, the
result, making it work, what Meridian takes, and questions for the board)
and a case card on the roadmap. Notebooks and workbooks are unchanged.

Co-Authored-By: Claude Opus 5.5 <noreply@anthropic.com>
Claude-Session: https://claude.ai/code/session_018eon9HRtnFa7qqQVV4TcNe
</commit_message>
<xml_diff>
--- a/downloads/DCT_V2_Ch01_Slides.pptx
+++ b/downloads/DCT_V2_Ch01_Slides.pptx
@@ -29,9 +29,10 @@
     <p:sldId id="277" r:id="rId23"/>
     <p:sldId id="278" r:id="rId24"/>
     <p:sldId id="279" r:id="rId25"/>
+    <p:sldId id="280" r:id="rId26"/>
   </p:sldIdLst>
   <p:notesMasterIdLst>
-    <p:notesMasterId r:id="rId26"/>
+    <p:notesMasterId r:id="rId27"/>
   </p:notesMasterIdLst>
   <p:sldSz cx="12192000" cy="6858000"/>
   <p:notesSz cx="6858000" cy="12192000"/>
@@ -130,7 +131,7 @@
   <p:extLst>
     <p:ext uri="{521415D9-36F7-43E2-AB2F-B90AF26B5E84}">
       <p14:sectionLst xmlns:p14="http://schemas.microsoft.com/office/powerpoint/2010/main">
-        <p14:section name="Opening" id="{2fecca82-64fa-416e-6156-f70258350812}">
+        <p14:section name="Opening" id="{d1cbd760-5bcc-b8ef-4533-e749ea6de02c}">
           <p14:sldIdLst>
             <p14:sldId id="256"/>
             <p14:sldId id="257"/>
@@ -138,50 +139,50 @@
             <p14:sldId id="259"/>
           </p14:sldIdLst>
         </p14:section>
-        <p14:section name="1.1 Why Optimize?" id="{e9264c53-5f15-4bbb-403a-879037012fe5}">
+        <p14:section name="1.1 Why Optimize?" id="{7078a89c-145c-fc19-8b2a-4e55af226a7b}">
           <p14:sldIdLst>
             <p14:sldId id="260"/>
           </p14:sldIdLst>
         </p14:section>
-        <p14:section name="1.2 A Short History" id="{bf017f4f-6635-326c-0c85-0c0a9a039212}">
+        <p14:section name="1.2 A Short History" id="{f6c079d9-4bb7-9454-d7fc-88f08323b4e6}">
           <p14:sldIdLst>
             <p14:sldId id="261"/>
           </p14:sldIdLst>
         </p14:section>
-        <p14:section name="1.3 The Canonical Form" id="{a9f5a304-6ea2-e4ef-969a-5e7a066164f4}">
+        <p14:section name="1.3 The Canonical Form" id="{f1c1cf5b-64a5-28d4-a090-91b2d4a0fec0}">
           <p14:sldIdLst>
             <p14:sldId id="262"/>
             <p14:sldId id="263"/>
           </p14:sldIdLst>
         </p14:section>
-        <p14:section name="1.4 Decision Spaces" id="{cfd6bf66-797e-6c85-923d-3e04d7f2da26}">
+        <p14:section name="1.4 Decision Spaces" id="{2ee58bd4-3812-a16d-6cbc-ab3f859865d2}">
           <p14:sldIdLst>
             <p14:sldId id="264"/>
             <p14:sldId id="265"/>
           </p14:sldIdLst>
         </p14:section>
-        <p14:section name="1.5 What the Objective Decides" id="{c4859754-6c46-2812-8b01-5db9858ed0ff}">
+        <p14:section name="1.5 What the Objective Decides" id="{32888dcb-1e6b-0398-c015-4607310897a0}">
           <p14:sldIdLst>
             <p14:sldId id="266"/>
             <p14:sldId id="267"/>
           </p14:sldIdLst>
         </p14:section>
-        <p14:section name="1.6 A Map of Volume II" id="{28bacc82-2547-169b-39d5-ff2a7ad0fd28}">
+        <p14:section name="1.6 A Map of Volume II" id="{c1087919-0b5d-5fba-6150-ea3850ec8f82}">
           <p14:sldIdLst>
             <p14:sldId id="268"/>
           </p14:sldIdLst>
         </p14:section>
-        <p14:section name="1.7 Ready to Optimize" id="{cf7de7ef-3d43-dc19-c567-9c17654304a5}">
+        <p14:section name="1.7 Ready to Optimize" id="{10c1ba43-aa1b-1d33-f271-8c6d79008f59}">
           <p14:sldIdLst>
             <p14:sldId id="269"/>
           </p14:sldIdLst>
         </p14:section>
-        <p14:section name="1.8 Learning with This Book" id="{99f72146-a5a8-cfbc-e817-5a2465d5544d}">
+        <p14:section name="1.8 Learning with This Book" id="{24137aa1-3a77-3891-b5a0-6105d5ca47bb}">
           <p14:sldIdLst>
             <p14:sldId id="270"/>
           </p14:sldIdLst>
         </p14:section>
-        <p14:section name="Worked Example 1.1" id="{63f163a6-0a86-1b02-57a9-5beb332706c9}">
+        <p14:section name="Worked Example 1.1" id="{a37e5010-2bfd-6ce3-6b17-1ee0ff4c0ac9}">
           <p14:sldIdLst>
             <p14:sldId id="271"/>
             <p14:sldId id="272"/>
@@ -190,16 +191,21 @@
             <p14:sldId id="275"/>
           </p14:sldIdLst>
         </p14:section>
-        <p14:section name="AXIOM Lab 2.1" id="{7d58e6f6-3c82-b958-1134-d65fb8eaa204}">
+        <p14:section name="In Practice" id="{eb17c9f6-de31-7f97-bfd8-2bab306264af}">
           <p14:sldIdLst>
             <p14:sldId id="276"/>
           </p14:sldIdLst>
         </p14:section>
-        <p14:section name="Close" id="{5f9d4a9c-1a8e-7b01-11d0-4a59b314e852}">
+        <p14:section name="AXIOM Lab 2.1" id="{adde6935-7656-0c91-ede5-5115057a8907}">
           <p14:sldIdLst>
             <p14:sldId id="277"/>
+          </p14:sldIdLst>
+        </p14:section>
+        <p14:section name="Close" id="{f5cf4f7b-cf75-011a-fcd5-983845ac38bc}">
+          <p14:sldIdLst>
             <p14:sldId id="278"/>
             <p14:sldId id="279"/>
+            <p14:sldId id="280"/>
           </p14:sldIdLst>
         </p14:section>
       </p14:sectionLst>
@@ -1750,7 +1756,7 @@
           <a:p>
             <a:r>
               <a:rPr lang="en-US" dirty="0"/>
-              <a:t>AXIOM Lab 2.1. What to look for: the refusal when a term is not declared (Proposition 1.1; gate R1); feasible packages that can only shrink as commitments are added (Proposition 1.2); the continuous answer as a floor no lumpy package beats (Theorem 1.3(v)); a rescaling that moves no decision and a reweighting that can (Theorem 1.4).</a:t>
+              <a:t>In Practice, Chapter 1: UPS Routes Fifty-Five Thousand Drivers a Day. A real organization's decision of this chapter's kind, told from its published record; every figure is cited in the book. The lesson for Meridian: ORION nearly failed on wrong map data and missing business rules: readiness first, then a gain measured in the field. Sources: Holland et al. (2017), Interfaces; INFORMS; Transport Topics (2016); UPS press releases (2015, 2020).</a:t>
             </a:r>
             <a:endParaRPr lang="en-US" dirty="0"/>
           </a:p>
@@ -1838,7 +1844,7 @@
           <a:p>
             <a:r>
               <a:rPr lang="en-US" dirty="0"/>
-              <a:t>Key Takeaways, Chapter 1.</a:t>
+              <a:t>AXIOM Lab 2.1. What to look for: the refusal when a term is not declared (Proposition 1.1; gate R1); feasible packages that can only shrink as commitments are added (Proposition 1.2); the continuous answer as a floor no lumpy package beats (Theorem 1.3(v)); a rescaling that moves no decision and a reweighting that can (Theorem 1.4).</a:t>
             </a:r>
             <a:endParaRPr lang="en-US" dirty="0"/>
           </a:p>
@@ -1926,7 +1932,7 @@
           <a:p>
             <a:r>
               <a:rPr lang="en-US" dirty="0"/>
-              <a:t>The notebook and workbook are on the course website, reached from the book's website, www.dynamiccorporatetransformation.com.</a:t>
+              <a:t>Key Takeaways, Chapter 1.</a:t>
             </a:r>
             <a:endParaRPr lang="en-US" dirty="0"/>
           </a:p>
@@ -2014,7 +2020,7 @@
           <a:p>
             <a:r>
               <a:rPr lang="en-US" dirty="0"/>
-              <a:t>Chapter 2, The General Enterprise Optimization Problem Revisited: the quantifier of a commitment (Chapter 2, Table 2.4, on the same two levers).</a:t>
+              <a:t>The notebook and workbook are on the course website, reached from the book's website, www.dynamiccorporatetransformation.com.</a:t>
             </a:r>
             <a:endParaRPr lang="en-US" dirty="0"/>
           </a:p>
@@ -2038,6 +2044,94 @@
             <a:fld id="{F7021451-1387-4CA6-816F-3879F97B5CBC}" type="slidenum">
               <a:rPr lang="en-US"/>
               <a:t>24</a:t>
+            </a:fld>
+            <a:endParaRPr lang="en-US"/>
+          </a:p>
+        </p:txBody>
+      </p:sp>
+    </p:spTree>
+    <p:extLst>
+      <p:ext uri="{BB962C8B-B14F-4D97-AF65-F5344CB8AC3E}">
+        <p14:creationId xmlns:p14="http://schemas.microsoft.com/office/powerpoint/2010/main" val="1024086991"/>
+      </p:ext>
+    </p:extLst>
+  </p:cSld>
+  <p:clrMapOvr>
+    <a:masterClrMapping/>
+  </p:clrMapOvr>
+</p:notes>
+</file>
+
+<file path=ppt/notesSlides/notesSlide25.xml><?xml version="1.0" encoding="utf-8"?>
+<p:notes xmlns:a="http://schemas.openxmlformats.org/drawingml/2006/main" xmlns:r="http://schemas.openxmlformats.org/officeDocument/2006/relationships" xmlns:p="http://schemas.openxmlformats.org/presentationml/2006/main">
+  <p:cSld>
+    <p:spTree>
+      <p:nvGrpSpPr>
+        <p:cNvPr id="1" name=""/>
+        <p:cNvGrpSpPr/>
+        <p:nvPr/>
+      </p:nvGrpSpPr>
+      <p:grpSpPr>
+        <a:xfrm>
+          <a:off x="0" y="0"/>
+          <a:ext cx="0" cy="0"/>
+          <a:chOff x="0" y="0"/>
+          <a:chExt cx="0" cy="0"/>
+        </a:xfrm>
+      </p:grpSpPr>
+      <p:sp>
+        <p:nvSpPr>
+          <p:cNvPr id="2" name="Slide Image Placeholder 1"/>
+          <p:cNvSpPr>
+            <a:spLocks noGrp="1" noRot="1" noChangeAspect="1"/>
+          </p:cNvSpPr>
+          <p:nvPr>
+            <p:ph type="sldImg"/>
+          </p:nvPr>
+        </p:nvSpPr>
+        <p:spPr/>
+      </p:sp>
+      <p:sp>
+        <p:nvSpPr>
+          <p:cNvPr id="3" name="Notes Placeholder 2"/>
+          <p:cNvSpPr>
+            <a:spLocks noGrp="1"/>
+          </p:cNvSpPr>
+          <p:nvPr>
+            <p:ph type="body" idx="1"/>
+          </p:nvPr>
+        </p:nvSpPr>
+        <p:spPr/>
+        <p:txBody>
+          <a:bodyPr/>
+          <a:lstStyle/>
+          <a:p>
+            <a:r>
+              <a:rPr lang="en-US" dirty="0"/>
+              <a:t>Chapter 2, The General Enterprise Optimization Problem Revisited: the quantifier of a commitment (Chapter 2, Table 2.4, on the same two levers).</a:t>
+            </a:r>
+            <a:endParaRPr lang="en-US" dirty="0"/>
+          </a:p>
+        </p:txBody>
+      </p:sp>
+      <p:sp>
+        <p:nvSpPr>
+          <p:cNvPr id="4" name="Slide Number Placeholder 3"/>
+          <p:cNvSpPr>
+            <a:spLocks noGrp="1"/>
+          </p:cNvSpPr>
+          <p:nvPr>
+            <p:ph type="sldNum" sz="quarter" idx="10"/>
+          </p:nvPr>
+        </p:nvSpPr>
+        <p:spPr/>
+        <p:txBody>
+          <a:bodyPr/>
+          <a:lstStyle/>
+          <a:p>
+            <a:fld id="{F7021451-1387-4CA6-816F-3879F97B5CBC}" type="slidenum">
+              <a:rPr lang="en-US"/>
+              <a:t>25</a:t>
             </a:fld>
             <a:endParaRPr lang="en-US"/>
           </a:p>
@@ -12476,7 +12570,7 @@
                   <a:schemeClr val="accent1"/>
                 </a:solidFill>
               </a:rPr>
-              <a:t>AXIOM LAB 2.1 · MODULE AXIOM-01</a:t>
+              <a:t>IN PRACTICE · UPS ORION</a:t>
             </a:r>
             <a:endParaRPr lang="en-US" sz="1200" dirty="0"/>
           </a:p>
@@ -12517,804 +12611,26 @@
                 <a:ea typeface="Cambria" pitchFamily="34" charset="-122"/>
                 <a:cs typeface="Cambria" pitchFamily="34" charset="-120"/>
               </a:rPr>
-              <a:t>From question to solvable problem, in AXIOM</a:t>
+              <a:t>UPS routes 55,000 drivers with a heuristic</a:t>
             </a:r>
             <a:endParaRPr lang="en-US" sz="3200" dirty="0"/>
           </a:p>
         </p:txBody>
       </p:sp>
-      <p:pic>
-        <p:nvPicPr>
-          <p:cNvPr id="5" name="AXIOM logo" descr="AXIOM">    </p:cNvPr>
-          <p:cNvPicPr>
-            <a:picLocks noChangeAspect="1"/>
-          </p:cNvPicPr>
-          <p:nvPr/>
-        </p:nvPicPr>
-        <p:blipFill>
-          <a:blip r:embed="rId1"/>
-          <a:stretch>
-            <a:fillRect/>
-          </a:stretch>
-        </p:blipFill>
-        <p:spPr>
-          <a:xfrm>
-            <a:off x="9539935" y="310896"/>
-            <a:ext cx="2103120" cy="420624"/>
-          </a:xfrm>
-          <a:prstGeom prst="rect">
-            <a:avLst/>
-          </a:prstGeom>
-        </p:spPr>
-      </p:pic>
-      <p:sp>
-        <p:nvSpPr>
-          <p:cNvPr id="6" name="Situation"/>
-          <p:cNvSpPr txBox="1"/>
-          <p:nvPr/>
-        </p:nvSpPr>
-        <p:spPr>
-          <a:xfrm>
-            <a:off x="548640" y="1645920"/>
-            <a:ext cx="11094415" cy="777240"/>
-          </a:xfrm>
-          <a:prstGeom prst="rect">
-            <a:avLst/>
-          </a:prstGeom>
-          <a:noFill/>
-          <a:ln/>
-        </p:spPr>
-        <p:txBody>
-          <a:bodyPr wrap="square" lIns="0" tIns="0" rIns="0" bIns="0" rtlCol="0" anchor="t"/>
-          <a:lstStyle/>
-          <a:p>
-            <a:pPr indent="0" marL="0">
-              <a:buNone/>
-            </a:pPr>
-            <a:r>
-              <a:rPr lang="en-US" sz="1500" dirty="0">
-                <a:solidFill>
-                  <a:schemeClr val="tx1"/>
-                </a:solidFill>
-              </a:rPr>
-              <a:t>Meridian's board wants to know what an optimizer adds to the analysis it already has, and the chief financial officer must turn Volume I's answer into a package the bank and the program office can sign. Open AXIOM, choose Lab 2.1 and load the Meridian digital program.</a:t>
-            </a:r>
-            <a:endParaRPr lang="en-US" sz="1500" dirty="0"/>
-          </a:p>
-        </p:txBody>
-      </p:sp>
-      <p:sp>
-        <p:nvSpPr>
-          <p:cNvPr id="7" name="Flow line"/>
+      <p:sp>
+        <p:nvSpPr>
+          <p:cNvPr id="5" name="Card"/>
           <p:cNvSpPr/>
           <p:nvPr/>
         </p:nvSpPr>
         <p:spPr>
           <a:xfrm>
-            <a:off x="1658082" y="2880360"/>
-            <a:ext cx="8875532" cy="0"/>
-          </a:xfrm>
-          <a:prstGeom prst="line">
-            <a:avLst/>
-          </a:prstGeom>
-          <a:noFill/>
-          <a:ln w="25400">
-            <a:solidFill>
-              <a:srgbClr val="C4CBD8"/>
-            </a:solidFill>
-            <a:prstDash val="solid"/>
-          </a:ln>
-        </p:spPr>
-      </p:sp>
-      <p:sp>
-        <p:nvSpPr>
-          <p:cNvPr id="8" name="Number"/>
-          <p:cNvSpPr/>
-          <p:nvPr/>
-        </p:nvSpPr>
-        <p:spPr>
-          <a:xfrm>
-            <a:off x="1383762" y="2606040"/>
-            <a:ext cx="548640" cy="548640"/>
-          </a:xfrm>
-          <a:prstGeom prst="ellipse">
-            <a:avLst/>
-          </a:prstGeom>
-          <a:solidFill>
-            <a:schemeClr val="accent1"/>
-          </a:solidFill>
-          <a:ln w="6350">
-            <a:solidFill>
-              <a:schemeClr val="accent1"/>
-            </a:solidFill>
-            <a:prstDash val="solid"/>
-          </a:ln>
-        </p:spPr>
-      </p:sp>
-      <p:sp>
-        <p:nvSpPr>
-          <p:cNvPr id="9" name="Text 5"/>
-          <p:cNvSpPr txBox="1"/>
-          <p:nvPr/>
-        </p:nvSpPr>
-        <p:spPr>
-          <a:xfrm>
-            <a:off x="1383762" y="2606040"/>
-            <a:ext cx="548640" cy="548640"/>
-          </a:xfrm>
-          <a:prstGeom prst="rect">
-            <a:avLst/>
-          </a:prstGeom>
-          <a:noFill/>
-          <a:ln/>
-        </p:spPr>
-        <p:txBody>
-          <a:bodyPr wrap="square" lIns="0" tIns="0" rIns="0" bIns="0" rtlCol="0" anchor="ctr"/>
-          <a:lstStyle/>
-          <a:p>
-            <a:pPr algn="ctr" indent="0" marL="0">
-              <a:buNone/>
-            </a:pPr>
-            <a:r>
-              <a:rPr lang="en-US" sz="1600" b="1" dirty="0">
-                <a:solidFill>
-                  <a:schemeClr val="bg1"/>
-                </a:solidFill>
-                <a:latin typeface="Calibri" pitchFamily="34" charset="0"/>
-                <a:ea typeface="Calibri" pitchFamily="34" charset="-122"/>
-                <a:cs typeface="Calibri" pitchFamily="34" charset="-120"/>
-              </a:rPr>
-              <a:t>1</a:t>
-            </a:r>
-            <a:endParaRPr lang="en-US" sz="1600" dirty="0"/>
-          </a:p>
-        </p:txBody>
-      </p:sp>
-      <p:sp>
-        <p:nvSpPr>
-          <p:cNvPr id="10" name="Flow head"/>
-          <p:cNvSpPr txBox="1"/>
-          <p:nvPr/>
-        </p:nvSpPr>
-        <p:spPr>
-          <a:xfrm>
-            <a:off x="621792" y="3291840"/>
-            <a:ext cx="2072579" cy="548640"/>
-          </a:xfrm>
-          <a:prstGeom prst="rect">
-            <a:avLst/>
-          </a:prstGeom>
-          <a:noFill/>
-          <a:ln/>
-        </p:spPr>
-        <p:txBody>
-          <a:bodyPr wrap="square" lIns="0" tIns="0" rIns="0" bIns="0" rtlCol="0" anchor="t"/>
-          <a:lstStyle/>
-          <a:p>
-            <a:pPr algn="ctr" indent="0" marL="0">
-              <a:buNone/>
-            </a:pPr>
-            <a:r>
-              <a:rPr lang="en-US" sz="1600" b="1" dirty="0">
-                <a:solidFill>
-                  <a:schemeClr val="tx1"/>
-                </a:solidFill>
-                <a:latin typeface="Cambria" pitchFamily="34" charset="0"/>
-                <a:ea typeface="Cambria" pitchFamily="34" charset="-122"/>
-                <a:cs typeface="Cambria" pitchFamily="34" charset="-120"/>
-              </a:rPr>
-              <a:t>Formulate</a:t>
-            </a:r>
-            <a:endParaRPr lang="en-US" sz="1600" dirty="0"/>
-          </a:p>
-        </p:txBody>
-      </p:sp>
-      <p:sp>
-        <p:nvSpPr>
-          <p:cNvPr id="11" name="Flow text"/>
-          <p:cNvSpPr txBox="1"/>
-          <p:nvPr/>
-        </p:nvSpPr>
-        <p:spPr>
-          <a:xfrm>
-            <a:off x="640080" y="3867912"/>
-            <a:ext cx="2036003" cy="1554480"/>
-          </a:xfrm>
-          <a:prstGeom prst="rect">
-            <a:avLst/>
-          </a:prstGeom>
-          <a:noFill/>
-          <a:ln/>
-        </p:spPr>
-        <p:txBody>
-          <a:bodyPr wrap="square" lIns="0" tIns="0" rIns="0" bIns="0" rtlCol="0" anchor="t"/>
-          <a:lstStyle/>
-          <a:p>
-            <a:pPr algn="ctr" indent="0" marL="0">
-              <a:buNone/>
-            </a:pPr>
-            <a:r>
-              <a:rPr lang="en-US" sz="1400" dirty="0">
-                <a:solidFill>
-                  <a:schemeClr val="tx2"/>
-                </a:solidFill>
-              </a:rPr>
-              <a:t>Enter the levers with owners and prices; delete the delay's declaration and watch the assistant refuse.</a:t>
-            </a:r>
-            <a:endParaRPr lang="en-US" sz="1400" dirty="0"/>
-          </a:p>
-        </p:txBody>
-      </p:sp>
-      <p:sp>
-        <p:nvSpPr>
-          <p:cNvPr id="12" name="Number"/>
-          <p:cNvSpPr/>
-          <p:nvPr/>
-        </p:nvSpPr>
-        <p:spPr>
-          <a:xfrm>
-            <a:off x="3602645" y="2606040"/>
-            <a:ext cx="548640" cy="548640"/>
-          </a:xfrm>
-          <a:prstGeom prst="ellipse">
-            <a:avLst/>
-          </a:prstGeom>
-          <a:solidFill>
-            <a:schemeClr val="accent1"/>
-          </a:solidFill>
-          <a:ln w="6350">
-            <a:solidFill>
-              <a:schemeClr val="accent1"/>
-            </a:solidFill>
-            <a:prstDash val="solid"/>
-          </a:ln>
-        </p:spPr>
-      </p:sp>
-      <p:sp>
-        <p:nvSpPr>
-          <p:cNvPr id="13" name="Text 9"/>
-          <p:cNvSpPr txBox="1"/>
-          <p:nvPr/>
-        </p:nvSpPr>
-        <p:spPr>
-          <a:xfrm>
-            <a:off x="3602645" y="2606040"/>
-            <a:ext cx="548640" cy="548640"/>
-          </a:xfrm>
-          <a:prstGeom prst="rect">
-            <a:avLst/>
-          </a:prstGeom>
-          <a:noFill/>
-          <a:ln/>
-        </p:spPr>
-        <p:txBody>
-          <a:bodyPr wrap="square" lIns="0" tIns="0" rIns="0" bIns="0" rtlCol="0" anchor="ctr"/>
-          <a:lstStyle/>
-          <a:p>
-            <a:pPr algn="ctr" indent="0" marL="0">
-              <a:buNone/>
-            </a:pPr>
-            <a:r>
-              <a:rPr lang="en-US" sz="1600" b="1" dirty="0">
-                <a:solidFill>
-                  <a:schemeClr val="bg1"/>
-                </a:solidFill>
-                <a:latin typeface="Calibri" pitchFamily="34" charset="0"/>
-                <a:ea typeface="Calibri" pitchFamily="34" charset="-122"/>
-                <a:cs typeface="Calibri" pitchFamily="34" charset="-120"/>
-              </a:rPr>
-              <a:t>2</a:t>
-            </a:r>
-            <a:endParaRPr lang="en-US" sz="1600" dirty="0"/>
-          </a:p>
-        </p:txBody>
-      </p:sp>
-      <p:sp>
-        <p:nvSpPr>
-          <p:cNvPr id="14" name="Flow head"/>
-          <p:cNvSpPr txBox="1"/>
-          <p:nvPr/>
-        </p:nvSpPr>
-        <p:spPr>
-          <a:xfrm>
-            <a:off x="2840675" y="3291840"/>
-            <a:ext cx="2072579" cy="548640"/>
-          </a:xfrm>
-          <a:prstGeom prst="rect">
-            <a:avLst/>
-          </a:prstGeom>
-          <a:noFill/>
-          <a:ln/>
-        </p:spPr>
-        <p:txBody>
-          <a:bodyPr wrap="square" lIns="0" tIns="0" rIns="0" bIns="0" rtlCol="0" anchor="t"/>
-          <a:lstStyle/>
-          <a:p>
-            <a:pPr algn="ctr" indent="0" marL="0">
-              <a:buNone/>
-            </a:pPr>
-            <a:r>
-              <a:rPr lang="en-US" sz="1600" b="1" dirty="0">
-                <a:solidFill>
-                  <a:schemeClr val="tx1"/>
-                </a:solidFill>
-                <a:latin typeface="Cambria" pitchFamily="34" charset="0"/>
-                <a:ea typeface="Cambria" pitchFamily="34" charset="-122"/>
-                <a:cs typeface="Cambria" pitchFamily="34" charset="-120"/>
-              </a:rPr>
-              <a:t>Run the gates</a:t>
-            </a:r>
-            <a:endParaRPr lang="en-US" sz="1600" dirty="0"/>
-          </a:p>
-        </p:txBody>
-      </p:sp>
-      <p:sp>
-        <p:nvSpPr>
-          <p:cNvPr id="15" name="Flow text"/>
-          <p:cNvSpPr txBox="1"/>
-          <p:nvPr/>
-        </p:nvSpPr>
-        <p:spPr>
-          <a:xfrm>
-            <a:off x="2858963" y="3867912"/>
-            <a:ext cx="2036003" cy="1554480"/>
-          </a:xfrm>
-          <a:prstGeom prst="rect">
-            <a:avLst/>
-          </a:prstGeom>
-          <a:noFill/>
-          <a:ln/>
-        </p:spPr>
-        <p:txBody>
-          <a:bodyPr wrap="square" lIns="0" tIns="0" rIns="0" bIns="0" rtlCol="0" anchor="t"/>
-          <a:lstStyle/>
-          <a:p>
-            <a:pPr algn="ctr" indent="0" marL="0">
-              <a:buNone/>
-            </a:pPr>
-            <a:r>
-              <a:rPr lang="en-US" sz="1400" dirty="0">
-                <a:solidFill>
-                  <a:schemeClr val="tx2"/>
-                </a:solidFill>
-              </a:rPr>
-              <a:t>Run (R1)–(R4); remove the standby line and rerun (R2): which commitments does the minimal infeasible set name?</a:t>
-            </a:r>
-            <a:endParaRPr lang="en-US" sz="1400" dirty="0"/>
-          </a:p>
-        </p:txBody>
-      </p:sp>
-      <p:sp>
-        <p:nvSpPr>
-          <p:cNvPr id="16" name="Number"/>
-          <p:cNvSpPr/>
-          <p:nvPr/>
-        </p:nvSpPr>
-        <p:spPr>
-          <a:xfrm>
-            <a:off x="5821528" y="2606040"/>
-            <a:ext cx="548640" cy="548640"/>
-          </a:xfrm>
-          <a:prstGeom prst="ellipse">
-            <a:avLst/>
-          </a:prstGeom>
-          <a:solidFill>
-            <a:schemeClr val="accent1"/>
-          </a:solidFill>
-          <a:ln w="6350">
-            <a:solidFill>
-              <a:schemeClr val="accent1"/>
-            </a:solidFill>
-            <a:prstDash val="solid"/>
-          </a:ln>
-        </p:spPr>
-      </p:sp>
-      <p:sp>
-        <p:nvSpPr>
-          <p:cNvPr id="17" name="Text 13"/>
-          <p:cNvSpPr txBox="1"/>
-          <p:nvPr/>
-        </p:nvSpPr>
-        <p:spPr>
-          <a:xfrm>
-            <a:off x="5821528" y="2606040"/>
-            <a:ext cx="548640" cy="548640"/>
-          </a:xfrm>
-          <a:prstGeom prst="rect">
-            <a:avLst/>
-          </a:prstGeom>
-          <a:noFill/>
-          <a:ln/>
-        </p:spPr>
-        <p:txBody>
-          <a:bodyPr wrap="square" lIns="0" tIns="0" rIns="0" bIns="0" rtlCol="0" anchor="ctr"/>
-          <a:lstStyle/>
-          <a:p>
-            <a:pPr algn="ctr" indent="0" marL="0">
-              <a:buNone/>
-            </a:pPr>
-            <a:r>
-              <a:rPr lang="en-US" sz="1600" b="1" dirty="0">
-                <a:solidFill>
-                  <a:schemeClr val="bg1"/>
-                </a:solidFill>
-                <a:latin typeface="Calibri" pitchFamily="34" charset="0"/>
-                <a:ea typeface="Calibri" pitchFamily="34" charset="-122"/>
-                <a:cs typeface="Calibri" pitchFamily="34" charset="-120"/>
-              </a:rPr>
-              <a:t>3</a:t>
-            </a:r>
-            <a:endParaRPr lang="en-US" sz="1600" dirty="0"/>
-          </a:p>
-        </p:txBody>
-      </p:sp>
-      <p:sp>
-        <p:nvSpPr>
-          <p:cNvPr id="18" name="Flow head"/>
-          <p:cNvSpPr txBox="1"/>
-          <p:nvPr/>
-        </p:nvSpPr>
-        <p:spPr>
-          <a:xfrm>
-            <a:off x="5059558" y="3291840"/>
-            <a:ext cx="2072579" cy="548640"/>
-          </a:xfrm>
-          <a:prstGeom prst="rect">
-            <a:avLst/>
-          </a:prstGeom>
-          <a:noFill/>
-          <a:ln/>
-        </p:spPr>
-        <p:txBody>
-          <a:bodyPr wrap="square" lIns="0" tIns="0" rIns="0" bIns="0" rtlCol="0" anchor="t"/>
-          <a:lstStyle/>
-          <a:p>
-            <a:pPr algn="ctr" indent="0" marL="0">
-              <a:buNone/>
-            </a:pPr>
-            <a:r>
-              <a:rPr lang="en-US" sz="1600" b="1" dirty="0">
-                <a:solidFill>
-                  <a:schemeClr val="tx1"/>
-                </a:solidFill>
-                <a:latin typeface="Cambria" pitchFamily="34" charset="0"/>
-                <a:ea typeface="Cambria" pitchFamily="34" charset="-122"/>
-                <a:cs typeface="Cambria" pitchFamily="34" charset="-120"/>
-              </a:rPr>
-              <a:t>Explore the decision space</a:t>
-            </a:r>
-            <a:endParaRPr lang="en-US" sz="1600" dirty="0"/>
-          </a:p>
-        </p:txBody>
-      </p:sp>
-      <p:sp>
-        <p:nvSpPr>
-          <p:cNvPr id="19" name="Flow text"/>
-          <p:cNvSpPr txBox="1"/>
-          <p:nvPr/>
-        </p:nvSpPr>
-        <p:spPr>
-          <a:xfrm>
-            <a:off x="5077846" y="3867912"/>
-            <a:ext cx="2036003" cy="1554480"/>
-          </a:xfrm>
-          <a:prstGeom prst="rect">
-            <a:avLst/>
-          </a:prstGeom>
-          <a:noFill/>
-          <a:ln/>
-        </p:spPr>
-        <p:txBody>
-          <a:bodyPr wrap="square" lIns="0" tIns="0" rIns="0" bIns="0" rtlCol="0" anchor="t"/>
-          <a:lstStyle/>
-          <a:p>
-            <a:pPr algn="ctr" indent="0" marL="0">
-              <a:buNone/>
-            </a:pPr>
-            <a:r>
-              <a:rPr lang="en-US" sz="1400" dirty="0">
-                <a:solidFill>
-                  <a:schemeClr val="tx2"/>
-                </a:solidFill>
-              </a:rPr>
-              <a:t>Switch to $50m tranches and whole quarters; count the packages and compare the cheapest with the roundings.</a:t>
-            </a:r>
-            <a:endParaRPr lang="en-US" sz="1400" dirty="0"/>
-          </a:p>
-        </p:txBody>
-      </p:sp>
-      <p:sp>
-        <p:nvSpPr>
-          <p:cNvPr id="20" name="Number"/>
-          <p:cNvSpPr/>
-          <p:nvPr/>
-        </p:nvSpPr>
-        <p:spPr>
-          <a:xfrm>
-            <a:off x="8040411" y="2606040"/>
-            <a:ext cx="548640" cy="548640"/>
-          </a:xfrm>
-          <a:prstGeom prst="ellipse">
-            <a:avLst/>
-          </a:prstGeom>
-          <a:solidFill>
-            <a:schemeClr val="accent1"/>
-          </a:solidFill>
-          <a:ln w="6350">
-            <a:solidFill>
-              <a:schemeClr val="accent1"/>
-            </a:solidFill>
-            <a:prstDash val="solid"/>
-          </a:ln>
-        </p:spPr>
-      </p:sp>
-      <p:sp>
-        <p:nvSpPr>
-          <p:cNvPr id="21" name="Text 17"/>
-          <p:cNvSpPr txBox="1"/>
-          <p:nvPr/>
-        </p:nvSpPr>
-        <p:spPr>
-          <a:xfrm>
-            <a:off x="8040411" y="2606040"/>
-            <a:ext cx="548640" cy="548640"/>
-          </a:xfrm>
-          <a:prstGeom prst="rect">
-            <a:avLst/>
-          </a:prstGeom>
-          <a:noFill/>
-          <a:ln/>
-        </p:spPr>
-        <p:txBody>
-          <a:bodyPr wrap="square" lIns="0" tIns="0" rIns="0" bIns="0" rtlCol="0" anchor="ctr"/>
-          <a:lstStyle/>
-          <a:p>
-            <a:pPr algn="ctr" indent="0" marL="0">
-              <a:buNone/>
-            </a:pPr>
-            <a:r>
-              <a:rPr lang="en-US" sz="1600" b="1" dirty="0">
-                <a:solidFill>
-                  <a:schemeClr val="bg1"/>
-                </a:solidFill>
-                <a:latin typeface="Calibri" pitchFamily="34" charset="0"/>
-                <a:ea typeface="Calibri" pitchFamily="34" charset="-122"/>
-                <a:cs typeface="Calibri" pitchFamily="34" charset="-120"/>
-              </a:rPr>
-              <a:t>4</a:t>
-            </a:r>
-            <a:endParaRPr lang="en-US" sz="1600" dirty="0"/>
-          </a:p>
-        </p:txBody>
-      </p:sp>
-      <p:sp>
-        <p:nvSpPr>
-          <p:cNvPr id="22" name="Flow head"/>
-          <p:cNvSpPr txBox="1"/>
-          <p:nvPr/>
-        </p:nvSpPr>
-        <p:spPr>
-          <a:xfrm>
-            <a:off x="7278441" y="3291840"/>
-            <a:ext cx="2072579" cy="548640"/>
-          </a:xfrm>
-          <a:prstGeom prst="rect">
-            <a:avLst/>
-          </a:prstGeom>
-          <a:noFill/>
-          <a:ln/>
-        </p:spPr>
-        <p:txBody>
-          <a:bodyPr wrap="square" lIns="0" tIns="0" rIns="0" bIns="0" rtlCol="0" anchor="t"/>
-          <a:lstStyle/>
-          <a:p>
-            <a:pPr algn="ctr" indent="0" marL="0">
-              <a:buNone/>
-            </a:pPr>
-            <a:r>
-              <a:rPr lang="en-US" sz="1600" b="1" dirty="0">
-                <a:solidFill>
-                  <a:schemeClr val="tx1"/>
-                </a:solidFill>
-                <a:latin typeface="Cambria" pitchFamily="34" charset="0"/>
-                <a:ea typeface="Cambria" pitchFamily="34" charset="-122"/>
-                <a:cs typeface="Cambria" pitchFamily="34" charset="-120"/>
-              </a:rPr>
-              <a:t>Rescale, then reweight</a:t>
-            </a:r>
-            <a:endParaRPr lang="en-US" sz="1600" dirty="0"/>
-          </a:p>
-        </p:txBody>
-      </p:sp>
-      <p:sp>
-        <p:nvSpPr>
-          <p:cNvPr id="23" name="Flow text"/>
-          <p:cNvSpPr txBox="1"/>
-          <p:nvPr/>
-        </p:nvSpPr>
-        <p:spPr>
-          <a:xfrm>
-            <a:off x="7296729" y="3867912"/>
-            <a:ext cx="2036003" cy="1554480"/>
-          </a:xfrm>
-          <a:prstGeom prst="rect">
-            <a:avLst/>
-          </a:prstGeom>
-          <a:noFill/>
-          <a:ln/>
-        </p:spPr>
-        <p:txBody>
-          <a:bodyPr wrap="square" lIns="0" tIns="0" rIns="0" bIns="0" rtlCol="0" anchor="t"/>
-          <a:lstStyle/>
-          <a:p>
-            <a:pPr algn="ctr" indent="0" marL="0">
-              <a:buNone/>
-            </a:pPr>
-            <a:r>
-              <a:rPr lang="en-US" sz="1400" dirty="0">
-                <a:solidFill>
-                  <a:schemeClr val="tx2"/>
-                </a:solidFill>
-              </a:rPr>
-              <a:t>State the costs after tax; value a quarter of delay at $4m and $16m.</a:t>
-            </a:r>
-            <a:endParaRPr lang="en-US" sz="1400" dirty="0"/>
-          </a:p>
-        </p:txBody>
-      </p:sp>
-      <p:sp>
-        <p:nvSpPr>
-          <p:cNvPr id="24" name="Number"/>
-          <p:cNvSpPr/>
-          <p:nvPr/>
-        </p:nvSpPr>
-        <p:spPr>
-          <a:xfrm>
-            <a:off x="10259294" y="2606040"/>
-            <a:ext cx="548640" cy="548640"/>
-          </a:xfrm>
-          <a:prstGeom prst="ellipse">
-            <a:avLst/>
-          </a:prstGeom>
-          <a:solidFill>
-            <a:schemeClr val="accent1"/>
-          </a:solidFill>
-          <a:ln w="6350">
-            <a:solidFill>
-              <a:schemeClr val="accent1"/>
-            </a:solidFill>
-            <a:prstDash val="solid"/>
-          </a:ln>
-        </p:spPr>
-      </p:sp>
-      <p:sp>
-        <p:nvSpPr>
-          <p:cNvPr id="25" name="Text 21"/>
-          <p:cNvSpPr txBox="1"/>
-          <p:nvPr/>
-        </p:nvSpPr>
-        <p:spPr>
-          <a:xfrm>
-            <a:off x="10259294" y="2606040"/>
-            <a:ext cx="548640" cy="548640"/>
-          </a:xfrm>
-          <a:prstGeom prst="rect">
-            <a:avLst/>
-          </a:prstGeom>
-          <a:noFill/>
-          <a:ln/>
-        </p:spPr>
-        <p:txBody>
-          <a:bodyPr wrap="square" lIns="0" tIns="0" rIns="0" bIns="0" rtlCol="0" anchor="ctr"/>
-          <a:lstStyle/>
-          <a:p>
-            <a:pPr algn="ctr" indent="0" marL="0">
-              <a:buNone/>
-            </a:pPr>
-            <a:r>
-              <a:rPr lang="en-US" sz="1600" b="1" dirty="0">
-                <a:solidFill>
-                  <a:schemeClr val="bg1"/>
-                </a:solidFill>
-                <a:latin typeface="Calibri" pitchFamily="34" charset="0"/>
-                <a:ea typeface="Calibri" pitchFamily="34" charset="-122"/>
-                <a:cs typeface="Calibri" pitchFamily="34" charset="-120"/>
-              </a:rPr>
-              <a:t>5</a:t>
-            </a:r>
-            <a:endParaRPr lang="en-US" sz="1600" dirty="0"/>
-          </a:p>
-        </p:txBody>
-      </p:sp>
-      <p:sp>
-        <p:nvSpPr>
-          <p:cNvPr id="26" name="Flow head"/>
-          <p:cNvSpPr txBox="1"/>
-          <p:nvPr/>
-        </p:nvSpPr>
-        <p:spPr>
-          <a:xfrm>
-            <a:off x="9497324" y="3291840"/>
-            <a:ext cx="2072579" cy="548640"/>
-          </a:xfrm>
-          <a:prstGeom prst="rect">
-            <a:avLst/>
-          </a:prstGeom>
-          <a:noFill/>
-          <a:ln/>
-        </p:spPr>
-        <p:txBody>
-          <a:bodyPr wrap="square" lIns="0" tIns="0" rIns="0" bIns="0" rtlCol="0" anchor="t"/>
-          <a:lstStyle/>
-          <a:p>
-            <a:pPr algn="ctr" indent="0" marL="0">
-              <a:buNone/>
-            </a:pPr>
-            <a:r>
-              <a:rPr lang="en-US" sz="1600" b="1" dirty="0">
-                <a:solidFill>
-                  <a:schemeClr val="tx1"/>
-                </a:solidFill>
-                <a:latin typeface="Cambria" pitchFamily="34" charset="0"/>
-                <a:ea typeface="Cambria" pitchFamily="34" charset="-122"/>
-                <a:cs typeface="Cambria" pitchFamily="34" charset="-120"/>
-              </a:rPr>
-              <a:t>Add a commitment</a:t>
-            </a:r>
-            <a:endParaRPr lang="en-US" sz="1600" dirty="0"/>
-          </a:p>
-        </p:txBody>
-      </p:sp>
-      <p:sp>
-        <p:nvSpPr>
-          <p:cNvPr id="27" name="Flow text"/>
-          <p:cNvSpPr txBox="1"/>
-          <p:nvPr/>
-        </p:nvSpPr>
-        <p:spPr>
-          <a:xfrm>
-            <a:off x="9515612" y="3867912"/>
-            <a:ext cx="2036003" cy="1554480"/>
-          </a:xfrm>
-          <a:prstGeom prst="rect">
-            <a:avLst/>
-          </a:prstGeom>
-          <a:noFill/>
-          <a:ln/>
-        </p:spPr>
-        <p:txBody>
-          <a:bodyPr wrap="square" lIns="0" tIns="0" rIns="0" bIns="0" rtlCol="0" anchor="t"/>
-          <a:lstStyle/>
-          <a:p>
-            <a:pPr algn="ctr" indent="0" marL="0">
-              <a:buNone/>
-            </a:pPr>
-            <a:r>
-              <a:rPr lang="en-US" sz="1400" dirty="0">
-                <a:solidFill>
-                  <a:schemeClr val="tx2"/>
-                </a:solidFill>
-              </a:rPr>
-              <a:t>Add the capability floor and the covenant with the line fully drawn: the feasible packages can only shrink.</a:t>
-            </a:r>
-            <a:endParaRPr lang="en-US" sz="1400" dirty="0"/>
-          </a:p>
-        </p:txBody>
-      </p:sp>
-      <p:sp>
-        <p:nvSpPr>
-          <p:cNvPr id="28" name="Deliverable card"/>
-          <p:cNvSpPr/>
-          <p:nvPr/>
-        </p:nvSpPr>
-        <p:spPr>
-          <a:xfrm>
-            <a:off x="548640" y="5486400"/>
-            <a:ext cx="11094415" cy="685800"/>
+            <a:off x="548640" y="1691640"/>
+            <a:ext cx="3515258" cy="2103120"/>
           </a:xfrm>
           <a:prstGeom prst="roundRect">
             <a:avLst>
-              <a:gd name="adj" fmla="val 10667"/>
+              <a:gd name="adj" fmla="val 3478"/>
             </a:avLst>
           </a:prstGeom>
           <a:solidFill>
@@ -13330,14 +12646,14 @@
       </p:sp>
       <p:sp>
         <p:nvSpPr>
-          <p:cNvPr id="29" name="Deliverable"/>
+          <p:cNvPr id="6" name="Card label"/>
           <p:cNvSpPr txBox="1"/>
           <p:nvPr/>
         </p:nvSpPr>
         <p:spPr>
           <a:xfrm>
-            <a:off x="777240" y="5559552"/>
-            <a:ext cx="10637215" cy="539496"/>
+            <a:off x="731520" y="1819656"/>
+            <a:ext cx="3149498" cy="310896"/>
           </a:xfrm>
           <a:prstGeom prst="rect">
             <a:avLst/>
@@ -13353,22 +12669,779 @@
               <a:buNone/>
             </a:pPr>
             <a:r>
-              <a:rPr lang="en-US" sz="1400" b="1" dirty="0">
+              <a:rPr lang="en-US" sz="1300" b="1" dirty="0">
+                <a:solidFill>
+                  <a:schemeClr val="accent1"/>
+                </a:solidFill>
+              </a:rPr>
+              <a:t>The decision</a:t>
+            </a:r>
+            <a:endParaRPr lang="en-US" sz="1300" dirty="0"/>
+          </a:p>
+        </p:txBody>
+      </p:sp>
+      <p:sp>
+        <p:nvSpPr>
+          <p:cNvPr id="7" name="Card head"/>
+          <p:cNvSpPr txBox="1"/>
+          <p:nvPr/>
+        </p:nvSpPr>
+        <p:spPr>
+          <a:xfrm>
+            <a:off x="731520" y="2148840"/>
+            <a:ext cx="3149498" cy="576072"/>
+          </a:xfrm>
+          <a:prstGeom prst="rect">
+            <a:avLst/>
+          </a:prstGeom>
+          <a:noFill/>
+          <a:ln/>
+        </p:spPr>
+        <p:txBody>
+          <a:bodyPr wrap="square" lIns="0" tIns="0" rIns="0" bIns="0" rtlCol="0" anchor="t"/>
+          <a:lstStyle/>
+          <a:p>
+            <a:pPr indent="0" marL="0">
+              <a:buNone/>
+            </a:pPr>
+            <a:r>
+              <a:rPr lang="en-US" sz="1600" b="1" dirty="0">
                 <a:solidFill>
                   <a:schemeClr val="tx1"/>
                 </a:solidFill>
-              </a:rPr>
-              <a:t>Deliverable:</a:t>
-            </a:r>
-            <a:r>
-              <a:rPr lang="en-US" sz="1400" dirty="0">
+                <a:latin typeface="Cambria" pitchFamily="34" charset="0"/>
+                <a:ea typeface="Cambria" pitchFamily="34" charset="-122"/>
+                <a:cs typeface="Cambria" pitchFamily="34" charset="-120"/>
+              </a:rPr>
+              <a:t>The order of stops, every day</a:t>
+            </a:r>
+            <a:endParaRPr lang="en-US" sz="1600" dirty="0"/>
+          </a:p>
+        </p:txBody>
+      </p:sp>
+      <p:sp>
+        <p:nvSpPr>
+          <p:cNvPr id="8" name="Card text"/>
+          <p:cNvSpPr txBox="1"/>
+          <p:nvPr/>
+        </p:nvSpPr>
+        <p:spPr>
+          <a:xfrm>
+            <a:off x="731520" y="2798064"/>
+            <a:ext cx="3149498" cy="868680"/>
+          </a:xfrm>
+          <a:prstGeom prst="rect">
+            <a:avLst/>
+          </a:prstGeom>
+          <a:noFill/>
+          <a:ln/>
+        </p:spPr>
+        <p:txBody>
+          <a:bodyPr wrap="square" lIns="0" tIns="0" rIns="0" bIns="0" rtlCol="0" anchor="t"/>
+          <a:lstStyle/>
+          <a:p>
+            <a:pPr indent="0" marL="0">
+              <a:buNone/>
+            </a:pPr>
+            <a:r>
+              <a:rPr lang="en-US" sz="1300" dirty="0">
+                <a:solidFill>
+                  <a:schemeClr val="tx2"/>
+                </a:solidFill>
+              </a:rPr>
+              <a:t>A typical U.S. driver serves 140 to 160 stops; one mile per driver per day is worth about $50m a year.</a:t>
+            </a:r>
+            <a:endParaRPr lang="en-US" sz="1300" dirty="0"/>
+          </a:p>
+        </p:txBody>
+      </p:sp>
+      <p:sp>
+        <p:nvSpPr>
+          <p:cNvPr id="9" name="Card"/>
+          <p:cNvSpPr/>
+          <p:nvPr/>
+        </p:nvSpPr>
+        <p:spPr>
+          <a:xfrm>
+            <a:off x="4338218" y="1691640"/>
+            <a:ext cx="3515258" cy="2103120"/>
+          </a:xfrm>
+          <a:prstGeom prst="roundRect">
+            <a:avLst>
+              <a:gd name="adj" fmla="val 3478"/>
+            </a:avLst>
+          </a:prstGeom>
+          <a:solidFill>
+            <a:schemeClr val="bg2"/>
+          </a:solidFill>
+          <a:ln w="9525">
+            <a:solidFill>
+              <a:srgbClr val="C4CBD8"/>
+            </a:solidFill>
+            <a:prstDash val="solid"/>
+          </a:ln>
+        </p:spPr>
+      </p:sp>
+      <p:sp>
+        <p:nvSpPr>
+          <p:cNvPr id="10" name="Card label"/>
+          <p:cNvSpPr txBox="1"/>
+          <p:nvPr/>
+        </p:nvSpPr>
+        <p:spPr>
+          <a:xfrm>
+            <a:off x="4521098" y="1819656"/>
+            <a:ext cx="3149498" cy="310896"/>
+          </a:xfrm>
+          <a:prstGeom prst="rect">
+            <a:avLst/>
+          </a:prstGeom>
+          <a:noFill/>
+          <a:ln/>
+        </p:spPr>
+        <p:txBody>
+          <a:bodyPr wrap="square" lIns="0" tIns="0" rIns="0" bIns="0" rtlCol="0" anchor="ctr"/>
+          <a:lstStyle/>
+          <a:p>
+            <a:pPr indent="0" marL="0">
+              <a:buNone/>
+            </a:pPr>
+            <a:r>
+              <a:rPr lang="en-US" sz="1300" b="1" dirty="0">
+                <a:solidFill>
+                  <a:schemeClr val="accent1"/>
+                </a:solidFill>
+              </a:rPr>
+              <a:t>The method</a:t>
+            </a:r>
+            <a:endParaRPr lang="en-US" sz="1300" dirty="0"/>
+          </a:p>
+        </p:txBody>
+      </p:sp>
+      <p:sp>
+        <p:nvSpPr>
+          <p:cNvPr id="11" name="Card head"/>
+          <p:cNvSpPr txBox="1"/>
+          <p:nvPr/>
+        </p:nvSpPr>
+        <p:spPr>
+          <a:xfrm>
+            <a:off x="4521098" y="2148840"/>
+            <a:ext cx="3149498" cy="576072"/>
+          </a:xfrm>
+          <a:prstGeom prst="rect">
+            <a:avLst/>
+          </a:prstGeom>
+          <a:noFill/>
+          <a:ln/>
+        </p:spPr>
+        <p:txBody>
+          <a:bodyPr wrap="square" lIns="0" tIns="0" rIns="0" bIns="0" rtlCol="0" anchor="t"/>
+          <a:lstStyle/>
+          <a:p>
+            <a:pPr indent="0" marL="0">
+              <a:buNone/>
+            </a:pPr>
+            <a:r>
+              <a:rPr lang="en-US" sz="1600" b="1" dirty="0">
                 <a:solidFill>
                   <a:schemeClr val="tx1"/>
                 </a:solidFill>
-              </a:rPr>
-              <a:t> a one-page note to the board: the package to sign, its odds and cost, what the lumps cost, which declaration moves the answer most, and the certificates that support each number. About 60 minutes.</a:t>
-            </a:r>
-            <a:endParaRPr lang="en-US" sz="1400" dirty="0"/>
+                <a:latin typeface="Cambria" pitchFamily="34" charset="0"/>
+                <a:ea typeface="Cambria" pitchFamily="34" charset="-122"/>
+                <a:cs typeface="Cambria" pitchFamily="34" charset="-120"/>
+              </a:rPr>
+              <a:t>Canonical form, solved fast</a:t>
+            </a:r>
+            <a:endParaRPr lang="en-US" sz="1600" dirty="0"/>
+          </a:p>
+        </p:txBody>
+      </p:sp>
+      <p:sp>
+        <p:nvSpPr>
+          <p:cNvPr id="12" name="Card text"/>
+          <p:cNvSpPr txBox="1"/>
+          <p:nvPr/>
+        </p:nvSpPr>
+        <p:spPr>
+          <a:xfrm>
+            <a:off x="4521098" y="2798064"/>
+            <a:ext cx="3149498" cy="868680"/>
+          </a:xfrm>
+          <a:prstGeom prst="rect">
+            <a:avLst/>
+          </a:prstGeom>
+          <a:noFill/>
+          <a:ln/>
+        </p:spPr>
+        <p:txBody>
+          <a:bodyPr wrap="square" lIns="0" tIns="0" rIns="0" bIns="0" rtlCol="0" anchor="t"/>
+          <a:lstStyle/>
+          <a:p>
+            <a:pPr indent="0" marL="0">
+              <a:buNone/>
+            </a:pPr>
+            <a:r>
+              <a:rPr lang="en-US" sz="1300" dirty="0">
+                <a:solidFill>
+                  <a:schemeClr val="tx2"/>
+                </a:solidFill>
+              </a:rPr>
+              <a:t>Yes-or-no sequencing, time windows and consistency bounds, solved by a metaheuristic without a certificate.</a:t>
+            </a:r>
+            <a:endParaRPr lang="en-US" sz="1300" dirty="0"/>
+          </a:p>
+        </p:txBody>
+      </p:sp>
+      <p:sp>
+        <p:nvSpPr>
+          <p:cNvPr id="13" name="Card"/>
+          <p:cNvSpPr/>
+          <p:nvPr/>
+        </p:nvSpPr>
+        <p:spPr>
+          <a:xfrm>
+            <a:off x="8127797" y="1691640"/>
+            <a:ext cx="3515258" cy="2103120"/>
+          </a:xfrm>
+          <a:prstGeom prst="roundRect">
+            <a:avLst>
+              <a:gd name="adj" fmla="val 3478"/>
+            </a:avLst>
+          </a:prstGeom>
+          <a:solidFill>
+            <a:schemeClr val="tx1"/>
+          </a:solidFill>
+          <a:ln w="9525">
+            <a:solidFill>
+              <a:srgbClr val="0F1E3D"/>
+            </a:solidFill>
+            <a:prstDash val="solid"/>
+          </a:ln>
+        </p:spPr>
+      </p:sp>
+      <p:sp>
+        <p:nvSpPr>
+          <p:cNvPr id="14" name="Card label"/>
+          <p:cNvSpPr txBox="1"/>
+          <p:nvPr/>
+        </p:nvSpPr>
+        <p:spPr>
+          <a:xfrm>
+            <a:off x="8310677" y="1819656"/>
+            <a:ext cx="3149498" cy="310896"/>
+          </a:xfrm>
+          <a:prstGeom prst="rect">
+            <a:avLst/>
+          </a:prstGeom>
+          <a:noFill/>
+          <a:ln/>
+        </p:spPr>
+        <p:txBody>
+          <a:bodyPr wrap="square" lIns="0" tIns="0" rIns="0" bIns="0" rtlCol="0" anchor="ctr"/>
+          <a:lstStyle/>
+          <a:p>
+            <a:pPr indent="0" marL="0">
+              <a:buNone/>
+            </a:pPr>
+            <a:r>
+              <a:rPr lang="en-US" sz="1300" b="1" dirty="0">
+                <a:solidFill>
+                  <a:schemeClr val="accent1"/>
+                </a:solidFill>
+              </a:rPr>
+              <a:t>The result</a:t>
+            </a:r>
+            <a:endParaRPr lang="en-US" sz="1300" dirty="0"/>
+          </a:p>
+        </p:txBody>
+      </p:sp>
+      <p:sp>
+        <p:nvSpPr>
+          <p:cNvPr id="15" name="Card head"/>
+          <p:cNvSpPr txBox="1"/>
+          <p:nvPr/>
+        </p:nvSpPr>
+        <p:spPr>
+          <a:xfrm>
+            <a:off x="8310677" y="2148840"/>
+            <a:ext cx="3149498" cy="576072"/>
+          </a:xfrm>
+          <a:prstGeom prst="rect">
+            <a:avLst/>
+          </a:prstGeom>
+          <a:noFill/>
+          <a:ln/>
+        </p:spPr>
+        <p:txBody>
+          <a:bodyPr wrap="square" lIns="0" tIns="0" rIns="0" bIns="0" rtlCol="0" anchor="t"/>
+          <a:lstStyle/>
+          <a:p>
+            <a:pPr indent="0" marL="0">
+              <a:buNone/>
+            </a:pPr>
+            <a:r>
+              <a:rPr lang="en-US" sz="1600" b="1" dirty="0">
+                <a:solidFill>
+                  <a:schemeClr val="bg1"/>
+                </a:solidFill>
+                <a:latin typeface="Cambria" pitchFamily="34" charset="0"/>
+                <a:ea typeface="Cambria" pitchFamily="34" charset="-122"/>
+                <a:cs typeface="Cambria" pitchFamily="34" charset="-120"/>
+              </a:rPr>
+              <a:t>$320m saved by December 2015</a:t>
+            </a:r>
+            <a:endParaRPr lang="en-US" sz="1600" dirty="0"/>
+          </a:p>
+        </p:txBody>
+      </p:sp>
+      <p:sp>
+        <p:nvSpPr>
+          <p:cNvPr id="16" name="Card text"/>
+          <p:cNvSpPr txBox="1"/>
+          <p:nvPr/>
+        </p:nvSpPr>
+        <p:spPr>
+          <a:xfrm>
+            <a:off x="8310677" y="2798064"/>
+            <a:ext cx="3149498" cy="868680"/>
+          </a:xfrm>
+          <a:prstGeom prst="rect">
+            <a:avLst/>
+          </a:prstGeom>
+          <a:noFill/>
+          <a:ln/>
+        </p:spPr>
+        <p:txBody>
+          <a:bodyPr wrap="square" lIns="0" tIns="0" rIns="0" bIns="0" rtlCol="0" anchor="t"/>
+          <a:lstStyle/>
+          <a:p>
+            <a:pPr indent="0" marL="0">
+              <a:buNone/>
+            </a:pPr>
+            <a:r>
+              <a:rPr lang="en-US" sz="1300" dirty="0">
+                <a:solidFill>
+                  <a:schemeClr val="bg2"/>
+                </a:solidFill>
+              </a:rPr>
+              <a:t>An expected $300–400m a year at full deployment; the 2016 Franz Edelman Award.</a:t>
+            </a:r>
+            <a:endParaRPr lang="en-US" sz="1300" dirty="0"/>
+          </a:p>
+        </p:txBody>
+      </p:sp>
+      <p:sp>
+        <p:nvSpPr>
+          <p:cNvPr id="17" name="Card"/>
+          <p:cNvSpPr/>
+          <p:nvPr/>
+        </p:nvSpPr>
+        <p:spPr>
+          <a:xfrm>
+            <a:off x="548640" y="4069080"/>
+            <a:ext cx="3515258" cy="2103120"/>
+          </a:xfrm>
+          <a:prstGeom prst="roundRect">
+            <a:avLst>
+              <a:gd name="adj" fmla="val 3478"/>
+            </a:avLst>
+          </a:prstGeom>
+          <a:solidFill>
+            <a:schemeClr val="bg2"/>
+          </a:solidFill>
+          <a:ln w="9525">
+            <a:solidFill>
+              <a:srgbClr val="C4CBD8"/>
+            </a:solidFill>
+            <a:prstDash val="solid"/>
+          </a:ln>
+        </p:spPr>
+      </p:sp>
+      <p:sp>
+        <p:nvSpPr>
+          <p:cNvPr id="18" name="Card label"/>
+          <p:cNvSpPr txBox="1"/>
+          <p:nvPr/>
+        </p:nvSpPr>
+        <p:spPr>
+          <a:xfrm>
+            <a:off x="731520" y="4197096"/>
+            <a:ext cx="3149498" cy="310896"/>
+          </a:xfrm>
+          <a:prstGeom prst="rect">
+            <a:avLst/>
+          </a:prstGeom>
+          <a:noFill/>
+          <a:ln/>
+        </p:spPr>
+        <p:txBody>
+          <a:bodyPr wrap="square" lIns="0" tIns="0" rIns="0" bIns="0" rtlCol="0" anchor="ctr"/>
+          <a:lstStyle/>
+          <a:p>
+            <a:pPr indent="0" marL="0">
+              <a:buNone/>
+            </a:pPr>
+            <a:r>
+              <a:rPr lang="en-US" sz="1300" b="1" dirty="0">
+                <a:solidFill>
+                  <a:schemeClr val="accent1"/>
+                </a:solidFill>
+              </a:rPr>
+              <a:t>Making it work</a:t>
+            </a:r>
+            <a:endParaRPr lang="en-US" sz="1300" dirty="0"/>
+          </a:p>
+        </p:txBody>
+      </p:sp>
+      <p:sp>
+        <p:nvSpPr>
+          <p:cNvPr id="19" name="Card head"/>
+          <p:cNvSpPr txBox="1"/>
+          <p:nvPr/>
+        </p:nvSpPr>
+        <p:spPr>
+          <a:xfrm>
+            <a:off x="731520" y="4526280"/>
+            <a:ext cx="3149498" cy="576072"/>
+          </a:xfrm>
+          <a:prstGeom prst="rect">
+            <a:avLst/>
+          </a:prstGeom>
+          <a:noFill/>
+          <a:ln/>
+        </p:spPr>
+        <p:txBody>
+          <a:bodyPr wrap="square" lIns="0" tIns="0" rIns="0" bIns="0" rtlCol="0" anchor="t"/>
+          <a:lstStyle/>
+          <a:p>
+            <a:pPr indent="0" marL="0">
+              <a:buNone/>
+            </a:pPr>
+            <a:r>
+              <a:rPr lang="en-US" sz="1600" b="1" dirty="0">
+                <a:solidFill>
+                  <a:schemeClr val="tx1"/>
+                </a:solidFill>
+                <a:latin typeface="Cambria" pitchFamily="34" charset="0"/>
+                <a:ea typeface="Cambria" pitchFamily="34" charset="-122"/>
+                <a:cs typeface="Cambria" pitchFamily="34" charset="-120"/>
+              </a:rPr>
+              <a:t>Nearly ten years to deploy</a:t>
+            </a:r>
+            <a:endParaRPr lang="en-US" sz="1600" dirty="0"/>
+          </a:p>
+        </p:txBody>
+      </p:sp>
+      <p:sp>
+        <p:nvSpPr>
+          <p:cNvPr id="20" name="Card text"/>
+          <p:cNvSpPr txBox="1"/>
+          <p:nvPr/>
+        </p:nvSpPr>
+        <p:spPr>
+          <a:xfrm>
+            <a:off x="731520" y="5175504"/>
+            <a:ext cx="3149498" cy="868680"/>
+          </a:xfrm>
+          <a:prstGeom prst="rect">
+            <a:avLst/>
+          </a:prstGeom>
+          <a:noFill/>
+          <a:ln/>
+        </p:spPr>
+        <p:txBody>
+          <a:bodyPr wrap="square" lIns="0" tIns="0" rIns="0" bIns="0" rtlCol="0" anchor="t"/>
+          <a:lstStyle/>
+          <a:p>
+            <a:pPr indent="0" marL="0">
+              <a:buNone/>
+            </a:pPr>
+            <a:r>
+              <a:rPr lang="en-US" sz="1300" dirty="0">
+                <a:solidFill>
+                  <a:schemeClr val="tx2"/>
+                </a:solidFill>
+              </a:rPr>
+              <a:t>Testing was halted over wrong map data and missing business rules; 700 people later deployed it, with two simulated rides per driver.</a:t>
+            </a:r>
+            <a:endParaRPr lang="en-US" sz="1300" dirty="0"/>
+          </a:p>
+        </p:txBody>
+      </p:sp>
+      <p:sp>
+        <p:nvSpPr>
+          <p:cNvPr id="21" name="Card"/>
+          <p:cNvSpPr/>
+          <p:nvPr/>
+        </p:nvSpPr>
+        <p:spPr>
+          <a:xfrm>
+            <a:off x="4338218" y="4069080"/>
+            <a:ext cx="3515258" cy="2103120"/>
+          </a:xfrm>
+          <a:prstGeom prst="roundRect">
+            <a:avLst>
+              <a:gd name="adj" fmla="val 3478"/>
+            </a:avLst>
+          </a:prstGeom>
+          <a:solidFill>
+            <a:schemeClr val="bg2"/>
+          </a:solidFill>
+          <a:ln w="9525">
+            <a:solidFill>
+              <a:srgbClr val="C4CBD8"/>
+            </a:solidFill>
+            <a:prstDash val="solid"/>
+          </a:ln>
+        </p:spPr>
+      </p:sp>
+      <p:sp>
+        <p:nvSpPr>
+          <p:cNvPr id="22" name="Card label"/>
+          <p:cNvSpPr txBox="1"/>
+          <p:nvPr/>
+        </p:nvSpPr>
+        <p:spPr>
+          <a:xfrm>
+            <a:off x="4521098" y="4197096"/>
+            <a:ext cx="3149498" cy="310896"/>
+          </a:xfrm>
+          <a:prstGeom prst="rect">
+            <a:avLst/>
+          </a:prstGeom>
+          <a:noFill/>
+          <a:ln/>
+        </p:spPr>
+        <p:txBody>
+          <a:bodyPr wrap="square" lIns="0" tIns="0" rIns="0" bIns="0" rtlCol="0" anchor="ctr"/>
+          <a:lstStyle/>
+          <a:p>
+            <a:pPr indent="0" marL="0">
+              <a:buNone/>
+            </a:pPr>
+            <a:r>
+              <a:rPr lang="en-US" sz="1300" b="1" dirty="0">
+                <a:solidFill>
+                  <a:schemeClr val="accent1"/>
+                </a:solidFill>
+              </a:rPr>
+              <a:t>What Meridian takes</a:t>
+            </a:r>
+            <a:endParaRPr lang="en-US" sz="1300" dirty="0"/>
+          </a:p>
+        </p:txBody>
+      </p:sp>
+      <p:sp>
+        <p:nvSpPr>
+          <p:cNvPr id="23" name="Card head"/>
+          <p:cNvSpPr txBox="1"/>
+          <p:nvPr/>
+        </p:nvSpPr>
+        <p:spPr>
+          <a:xfrm>
+            <a:off x="4521098" y="4526280"/>
+            <a:ext cx="3149498" cy="576072"/>
+          </a:xfrm>
+          <a:prstGeom prst="rect">
+            <a:avLst/>
+          </a:prstGeom>
+          <a:noFill/>
+          <a:ln/>
+        </p:spPr>
+        <p:txBody>
+          <a:bodyPr wrap="square" lIns="0" tIns="0" rIns="0" bIns="0" rtlCol="0" anchor="t"/>
+          <a:lstStyle/>
+          <a:p>
+            <a:pPr indent="0" marL="0">
+              <a:buNone/>
+            </a:pPr>
+            <a:r>
+              <a:rPr lang="en-US" sz="1600" b="1" dirty="0">
+                <a:solidFill>
+                  <a:schemeClr val="tx1"/>
+                </a:solidFill>
+                <a:latin typeface="Cambria" pitchFamily="34" charset="0"/>
+                <a:ea typeface="Cambria" pitchFamily="34" charset="-122"/>
+                <a:cs typeface="Cambria" pitchFamily="34" charset="-120"/>
+              </a:rPr>
+              <a:t>Readiness before solvers</a:t>
+            </a:r>
+            <a:endParaRPr lang="en-US" sz="1600" dirty="0"/>
+          </a:p>
+        </p:txBody>
+      </p:sp>
+      <p:sp>
+        <p:nvSpPr>
+          <p:cNvPr id="24" name="Card text"/>
+          <p:cNvSpPr txBox="1"/>
+          <p:nvPr/>
+        </p:nvSpPr>
+        <p:spPr>
+          <a:xfrm>
+            <a:off x="4521098" y="5175504"/>
+            <a:ext cx="3149498" cy="868680"/>
+          </a:xfrm>
+          <a:prstGeom prst="rect">
+            <a:avLst/>
+          </a:prstGeom>
+          <a:noFill/>
+          <a:ln/>
+        </p:spPr>
+        <p:txBody>
+          <a:bodyPr wrap="square" lIns="0" tIns="0" rIns="0" bIns="0" rtlCol="0" anchor="t"/>
+          <a:lstStyle/>
+          <a:p>
+            <a:pPr indent="0" marL="0">
+              <a:buNone/>
+            </a:pPr>
+            <a:r>
+              <a:rPr lang="en-US" sz="1300" dirty="0">
+                <a:solidFill>
+                  <a:schemeClr val="tx2"/>
+                </a:solidFill>
+              </a:rPr>
+              <a:t>The early failure was a readiness failure: inputs no one could vouch for, and commitments the model left out.</a:t>
+            </a:r>
+            <a:endParaRPr lang="en-US" sz="1300" dirty="0"/>
+          </a:p>
+        </p:txBody>
+      </p:sp>
+      <p:sp>
+        <p:nvSpPr>
+          <p:cNvPr id="25" name="Card"/>
+          <p:cNvSpPr/>
+          <p:nvPr/>
+        </p:nvSpPr>
+        <p:spPr>
+          <a:xfrm>
+            <a:off x="8127797" y="4069080"/>
+            <a:ext cx="3515258" cy="2103120"/>
+          </a:xfrm>
+          <a:prstGeom prst="roundRect">
+            <a:avLst>
+              <a:gd name="adj" fmla="val 3478"/>
+            </a:avLst>
+          </a:prstGeom>
+          <a:solidFill>
+            <a:schemeClr val="bg2"/>
+          </a:solidFill>
+          <a:ln w="9525">
+            <a:solidFill>
+              <a:srgbClr val="C4CBD8"/>
+            </a:solidFill>
+            <a:prstDash val="solid"/>
+          </a:ln>
+        </p:spPr>
+      </p:sp>
+      <p:sp>
+        <p:nvSpPr>
+          <p:cNvPr id="26" name="Card label"/>
+          <p:cNvSpPr txBox="1"/>
+          <p:nvPr/>
+        </p:nvSpPr>
+        <p:spPr>
+          <a:xfrm>
+            <a:off x="8310677" y="4197096"/>
+            <a:ext cx="3149498" cy="310896"/>
+          </a:xfrm>
+          <a:prstGeom prst="rect">
+            <a:avLst/>
+          </a:prstGeom>
+          <a:noFill/>
+          <a:ln/>
+        </p:spPr>
+        <p:txBody>
+          <a:bodyPr wrap="square" lIns="0" tIns="0" rIns="0" bIns="0" rtlCol="0" anchor="ctr"/>
+          <a:lstStyle/>
+          <a:p>
+            <a:pPr indent="0" marL="0">
+              <a:buNone/>
+            </a:pPr>
+            <a:r>
+              <a:rPr lang="en-US" sz="1300" b="1" dirty="0">
+                <a:solidFill>
+                  <a:schemeClr val="accent1"/>
+                </a:solidFill>
+              </a:rPr>
+              <a:t>For the board</a:t>
+            </a:r>
+            <a:endParaRPr lang="en-US" sz="1300" dirty="0"/>
+          </a:p>
+        </p:txBody>
+      </p:sp>
+      <p:sp>
+        <p:nvSpPr>
+          <p:cNvPr id="27" name="Card head"/>
+          <p:cNvSpPr txBox="1"/>
+          <p:nvPr/>
+        </p:nvSpPr>
+        <p:spPr>
+          <a:xfrm>
+            <a:off x="8310677" y="4526280"/>
+            <a:ext cx="3149498" cy="576072"/>
+          </a:xfrm>
+          <a:prstGeom prst="rect">
+            <a:avLst/>
+          </a:prstGeom>
+          <a:noFill/>
+          <a:ln/>
+        </p:spPr>
+        <p:txBody>
+          <a:bodyPr wrap="square" lIns="0" tIns="0" rIns="0" bIns="0" rtlCol="0" anchor="t"/>
+          <a:lstStyle/>
+          <a:p>
+            <a:pPr indent="0" marL="0">
+              <a:buNone/>
+            </a:pPr>
+            <a:r>
+              <a:rPr lang="en-US" sz="1600" b="1" dirty="0">
+                <a:solidFill>
+                  <a:schemeClr val="tx1"/>
+                </a:solidFill>
+                <a:latin typeface="Cambria" pitchFamily="34" charset="0"/>
+                <a:ea typeface="Cambria" pitchFamily="34" charset="-122"/>
+                <a:cs typeface="Cambria" pitchFamily="34" charset="-120"/>
+              </a:rPr>
+              <a:t>Which answer are we signing?</a:t>
+            </a:r>
+            <a:endParaRPr lang="en-US" sz="1600" dirty="0"/>
+          </a:p>
+        </p:txBody>
+      </p:sp>
+      <p:sp>
+        <p:nvSpPr>
+          <p:cNvPr id="28" name="Card text"/>
+          <p:cNvSpPr txBox="1"/>
+          <p:nvPr/>
+        </p:nvSpPr>
+        <p:spPr>
+          <a:xfrm>
+            <a:off x="8310677" y="5175504"/>
+            <a:ext cx="3149498" cy="868680"/>
+          </a:xfrm>
+          <a:prstGeom prst="rect">
+            <a:avLst/>
+          </a:prstGeom>
+          <a:noFill/>
+          <a:ln/>
+        </p:spPr>
+        <p:txBody>
+          <a:bodyPr wrap="square" lIns="0" tIns="0" rIns="0" bIns="0" rtlCol="0" anchor="t"/>
+          <a:lstStyle/>
+          <a:p>
+            <a:pPr indent="0" marL="0">
+              <a:buNone/>
+            </a:pPr>
+            <a:r>
+              <a:rPr lang="en-US" sz="1300" dirty="0">
+                <a:solidFill>
+                  <a:schemeClr val="tx2"/>
+                </a:solidFill>
+              </a:rPr>
+              <a:t>Does it come with a certificate, and if not, how is its gain measured?</a:t>
+            </a:r>
+            <a:endParaRPr lang="en-US" sz="1300" dirty="0"/>
           </a:p>
         </p:txBody>
       </p:sp>
@@ -13474,7 +13547,7 @@
                   <a:schemeClr val="accent1"/>
                 </a:solidFill>
               </a:rPr>
-              <a:t>KEY TAKEAWAYS</a:t>
+              <a:t>AXIOM LAB 2.1 · MODULE AXIOM-01</a:t>
             </a:r>
             <a:endParaRPr lang="en-US" sz="1200" dirty="0"/>
           </a:p>
@@ -13515,22 +13588,105 @@
                 <a:ea typeface="Cambria" pitchFamily="34" charset="-122"/>
                 <a:cs typeface="Cambria" pitchFamily="34" charset="-120"/>
               </a:rPr>
-              <a:t>What to carry forward</a:t>
+              <a:t>From question to solvable problem, in AXIOM</a:t>
             </a:r>
             <a:endParaRPr lang="en-US" sz="3200" dirty="0"/>
           </a:p>
         </p:txBody>
       </p:sp>
-      <p:sp>
-        <p:nvSpPr>
-          <p:cNvPr id="5" name="Number"/>
+      <p:pic>
+        <p:nvPicPr>
+          <p:cNvPr id="5" name="AXIOM logo" descr="AXIOM">    </p:cNvPr>
+          <p:cNvPicPr>
+            <a:picLocks noChangeAspect="1"/>
+          </p:cNvPicPr>
+          <p:nvPr/>
+        </p:nvPicPr>
+        <p:blipFill>
+          <a:blip r:embed="rId1"/>
+          <a:stretch>
+            <a:fillRect/>
+          </a:stretch>
+        </p:blipFill>
+        <p:spPr>
+          <a:xfrm>
+            <a:off x="9539935" y="310896"/>
+            <a:ext cx="2103120" cy="420624"/>
+          </a:xfrm>
+          <a:prstGeom prst="rect">
+            <a:avLst/>
+          </a:prstGeom>
+        </p:spPr>
+      </p:pic>
+      <p:sp>
+        <p:nvSpPr>
+          <p:cNvPr id="6" name="Situation"/>
+          <p:cNvSpPr txBox="1"/>
+          <p:nvPr/>
+        </p:nvSpPr>
+        <p:spPr>
+          <a:xfrm>
+            <a:off x="548640" y="1645920"/>
+            <a:ext cx="11094415" cy="777240"/>
+          </a:xfrm>
+          <a:prstGeom prst="rect">
+            <a:avLst/>
+          </a:prstGeom>
+          <a:noFill/>
+          <a:ln/>
+        </p:spPr>
+        <p:txBody>
+          <a:bodyPr wrap="square" lIns="0" tIns="0" rIns="0" bIns="0" rtlCol="0" anchor="t"/>
+          <a:lstStyle/>
+          <a:p>
+            <a:pPr indent="0" marL="0">
+              <a:buNone/>
+            </a:pPr>
+            <a:r>
+              <a:rPr lang="en-US" sz="1500" dirty="0">
+                <a:solidFill>
+                  <a:schemeClr val="tx1"/>
+                </a:solidFill>
+              </a:rPr>
+              <a:t>Meridian's board wants to know what an optimizer adds to the analysis it already has, and the chief financial officer must turn Volume I's answer into a package the bank and the program office can sign. Open AXIOM, choose Lab 2.1 and load the Meridian digital program.</a:t>
+            </a:r>
+            <a:endParaRPr lang="en-US" sz="1500" dirty="0"/>
+          </a:p>
+        </p:txBody>
+      </p:sp>
+      <p:sp>
+        <p:nvSpPr>
+          <p:cNvPr id="7" name="Flow line"/>
           <p:cNvSpPr/>
           <p:nvPr/>
         </p:nvSpPr>
         <p:spPr>
           <a:xfrm>
-            <a:off x="548640" y="1737360"/>
-            <a:ext cx="566928" cy="566928"/>
+            <a:off x="1658082" y="2880360"/>
+            <a:ext cx="8875532" cy="0"/>
+          </a:xfrm>
+          <a:prstGeom prst="line">
+            <a:avLst/>
+          </a:prstGeom>
+          <a:noFill/>
+          <a:ln w="25400">
+            <a:solidFill>
+              <a:srgbClr val="C4CBD8"/>
+            </a:solidFill>
+            <a:prstDash val="solid"/>
+          </a:ln>
+        </p:spPr>
+      </p:sp>
+      <p:sp>
+        <p:nvSpPr>
+          <p:cNvPr id="8" name="Number"/>
+          <p:cNvSpPr/>
+          <p:nvPr/>
+        </p:nvSpPr>
+        <p:spPr>
+          <a:xfrm>
+            <a:off x="1383762" y="2606040"/>
+            <a:ext cx="548640" cy="548640"/>
           </a:xfrm>
           <a:prstGeom prst="ellipse">
             <a:avLst/>
@@ -13548,14 +13704,14 @@
       </p:sp>
       <p:sp>
         <p:nvSpPr>
-          <p:cNvPr id="6" name="Text 3"/>
+          <p:cNvPr id="9" name="Text 5"/>
           <p:cNvSpPr txBox="1"/>
           <p:nvPr/>
         </p:nvSpPr>
         <p:spPr>
           <a:xfrm>
-            <a:off x="548640" y="1737360"/>
-            <a:ext cx="566928" cy="566928"/>
+            <a:off x="1383762" y="2606040"/>
+            <a:ext cx="548640" cy="548640"/>
           </a:xfrm>
           <a:prstGeom prst="rect">
             <a:avLst/>
@@ -13571,7 +13727,7 @@
               <a:buNone/>
             </a:pPr>
             <a:r>
-              <a:rPr lang="en-US" sz="1500" b="1" dirty="0">
+              <a:rPr lang="en-US" sz="1600" b="1" dirty="0">
                 <a:solidFill>
                   <a:schemeClr val="bg1"/>
                 </a:solidFill>
@@ -13581,56 +13737,95 @@
               </a:rPr>
               <a:t>1</a:t>
             </a:r>
-            <a:endParaRPr lang="en-US" sz="1500" dirty="0"/>
-          </a:p>
-        </p:txBody>
-      </p:sp>
-      <p:sp>
-        <p:nvSpPr>
-          <p:cNvPr id="7" name="Row text"/>
+            <a:endParaRPr lang="en-US" sz="1600" dirty="0"/>
+          </a:p>
+        </p:txBody>
+      </p:sp>
+      <p:sp>
+        <p:nvSpPr>
+          <p:cNvPr id="10" name="Flow head"/>
           <p:cNvSpPr txBox="1"/>
           <p:nvPr/>
         </p:nvSpPr>
         <p:spPr>
           <a:xfrm>
-            <a:off x="1325880" y="1691640"/>
-            <a:ext cx="10317175" cy="841248"/>
-          </a:xfrm>
-          <a:prstGeom prst="rect">
-            <a:avLst/>
-          </a:prstGeom>
-          <a:noFill/>
-          <a:ln/>
-        </p:spPr>
-        <p:txBody>
-          <a:bodyPr wrap="square" lIns="0" tIns="0" rIns="0" bIns="0" rtlCol="0" anchor="ctr"/>
-          <a:lstStyle/>
-          <a:p>
-            <a:pPr indent="0" marL="0">
-              <a:buNone/>
-            </a:pPr>
-            <a:r>
-              <a:rPr lang="en-US" sz="1500" dirty="0">
+            <a:off x="621792" y="3291840"/>
+            <a:ext cx="2072579" cy="548640"/>
+          </a:xfrm>
+          <a:prstGeom prst="rect">
+            <a:avLst/>
+          </a:prstGeom>
+          <a:noFill/>
+          <a:ln/>
+        </p:spPr>
+        <p:txBody>
+          <a:bodyPr wrap="square" lIns="0" tIns="0" rIns="0" bIns="0" rtlCol="0" anchor="t"/>
+          <a:lstStyle/>
+          <a:p>
+            <a:pPr algn="ctr" indent="0" marL="0">
+              <a:buNone/>
+            </a:pPr>
+            <a:r>
+              <a:rPr lang="en-US" sz="1600" b="1" dirty="0">
                 <a:solidFill>
                   <a:schemeClr val="tx1"/>
                 </a:solidFill>
-              </a:rPr>
-              <a:t>Analysis runs forward from a plan to its consequences; optimization runs backward from what the company wants and must respect to a plan. Both use the same declared model, and optimization needs every term of its problem declared.</a:t>
-            </a:r>
-            <a:endParaRPr lang="en-US" sz="1500" dirty="0"/>
-          </a:p>
-        </p:txBody>
-      </p:sp>
-      <p:sp>
-        <p:nvSpPr>
-          <p:cNvPr id="8" name="Number"/>
+                <a:latin typeface="Cambria" pitchFamily="34" charset="0"/>
+                <a:ea typeface="Cambria" pitchFamily="34" charset="-122"/>
+                <a:cs typeface="Cambria" pitchFamily="34" charset="-120"/>
+              </a:rPr>
+              <a:t>Formulate</a:t>
+            </a:r>
+            <a:endParaRPr lang="en-US" sz="1600" dirty="0"/>
+          </a:p>
+        </p:txBody>
+      </p:sp>
+      <p:sp>
+        <p:nvSpPr>
+          <p:cNvPr id="11" name="Flow text"/>
+          <p:cNvSpPr txBox="1"/>
+          <p:nvPr/>
+        </p:nvSpPr>
+        <p:spPr>
+          <a:xfrm>
+            <a:off x="640080" y="3867912"/>
+            <a:ext cx="2036003" cy="1554480"/>
+          </a:xfrm>
+          <a:prstGeom prst="rect">
+            <a:avLst/>
+          </a:prstGeom>
+          <a:noFill/>
+          <a:ln/>
+        </p:spPr>
+        <p:txBody>
+          <a:bodyPr wrap="square" lIns="0" tIns="0" rIns="0" bIns="0" rtlCol="0" anchor="t"/>
+          <a:lstStyle/>
+          <a:p>
+            <a:pPr algn="ctr" indent="0" marL="0">
+              <a:buNone/>
+            </a:pPr>
+            <a:r>
+              <a:rPr lang="en-US" sz="1400" dirty="0">
+                <a:solidFill>
+                  <a:schemeClr val="tx2"/>
+                </a:solidFill>
+              </a:rPr>
+              <a:t>Enter the levers with owners and prices; delete the delay's declaration and watch the assistant refuse.</a:t>
+            </a:r>
+            <a:endParaRPr lang="en-US" sz="1400" dirty="0"/>
+          </a:p>
+        </p:txBody>
+      </p:sp>
+      <p:sp>
+        <p:nvSpPr>
+          <p:cNvPr id="12" name="Number"/>
           <p:cNvSpPr/>
           <p:nvPr/>
         </p:nvSpPr>
         <p:spPr>
           <a:xfrm>
-            <a:off x="548640" y="2633472"/>
-            <a:ext cx="566928" cy="566928"/>
+            <a:off x="3602645" y="2606040"/>
+            <a:ext cx="548640" cy="548640"/>
           </a:xfrm>
           <a:prstGeom prst="ellipse">
             <a:avLst/>
@@ -13648,14 +13843,14 @@
       </p:sp>
       <p:sp>
         <p:nvSpPr>
-          <p:cNvPr id="9" name="Text 6"/>
+          <p:cNvPr id="13" name="Text 9"/>
           <p:cNvSpPr txBox="1"/>
           <p:nvPr/>
         </p:nvSpPr>
         <p:spPr>
           <a:xfrm>
-            <a:off x="548640" y="2633472"/>
-            <a:ext cx="566928" cy="566928"/>
+            <a:off x="3602645" y="2606040"/>
+            <a:ext cx="548640" cy="548640"/>
           </a:xfrm>
           <a:prstGeom prst="rect">
             <a:avLst/>
@@ -13671,7 +13866,7 @@
               <a:buNone/>
             </a:pPr>
             <a:r>
-              <a:rPr lang="en-US" sz="1500" b="1" dirty="0">
+              <a:rPr lang="en-US" sz="1600" b="1" dirty="0">
                 <a:solidFill>
                   <a:schemeClr val="bg1"/>
                 </a:solidFill>
@@ -13681,56 +13876,95 @@
               </a:rPr>
               <a:t>2</a:t>
             </a:r>
-            <a:endParaRPr lang="en-US" sz="1500" dirty="0"/>
-          </a:p>
-        </p:txBody>
-      </p:sp>
-      <p:sp>
-        <p:nvSpPr>
-          <p:cNvPr id="10" name="Row text"/>
+            <a:endParaRPr lang="en-US" sz="1600" dirty="0"/>
+          </a:p>
+        </p:txBody>
+      </p:sp>
+      <p:sp>
+        <p:nvSpPr>
+          <p:cNvPr id="14" name="Flow head"/>
           <p:cNvSpPr txBox="1"/>
           <p:nvPr/>
         </p:nvSpPr>
         <p:spPr>
           <a:xfrm>
-            <a:off x="1325880" y="2587752"/>
-            <a:ext cx="10317175" cy="841248"/>
-          </a:xfrm>
-          <a:prstGeom prst="rect">
-            <a:avLst/>
-          </a:prstGeom>
-          <a:noFill/>
-          <a:ln/>
-        </p:spPr>
-        <p:txBody>
-          <a:bodyPr wrap="square" lIns="0" tIns="0" rIns="0" bIns="0" rtlCol="0" anchor="ctr"/>
-          <a:lstStyle/>
-          <a:p>
-            <a:pPr indent="0" marL="0">
-              <a:buNone/>
-            </a:pPr>
-            <a:r>
-              <a:rPr lang="en-US" sz="1500" dirty="0">
+            <a:off x="2840675" y="3291840"/>
+            <a:ext cx="2072579" cy="548640"/>
+          </a:xfrm>
+          <a:prstGeom prst="rect">
+            <a:avLst/>
+          </a:prstGeom>
+          <a:noFill/>
+          <a:ln/>
+        </p:spPr>
+        <p:txBody>
+          <a:bodyPr wrap="square" lIns="0" tIns="0" rIns="0" bIns="0" rtlCol="0" anchor="t"/>
+          <a:lstStyle/>
+          <a:p>
+            <a:pPr algn="ctr" indent="0" marL="0">
+              <a:buNone/>
+            </a:pPr>
+            <a:r>
+              <a:rPr lang="en-US" sz="1600" b="1" dirty="0">
                 <a:solidFill>
                   <a:schemeClr val="tx1"/>
                 </a:solidFill>
-              </a:rPr>
-              <a:t>Every well-posed transformation decision fits one canonical form: decisions, an objective, commitments, and the company's dynamics, with nothing lost and nothing left to taste.</a:t>
-            </a:r>
-            <a:endParaRPr lang="en-US" sz="1500" dirty="0"/>
-          </a:p>
-        </p:txBody>
-      </p:sp>
-      <p:sp>
-        <p:nvSpPr>
-          <p:cNvPr id="11" name="Number"/>
+                <a:latin typeface="Cambria" pitchFamily="34" charset="0"/>
+                <a:ea typeface="Cambria" pitchFamily="34" charset="-122"/>
+                <a:cs typeface="Cambria" pitchFamily="34" charset="-120"/>
+              </a:rPr>
+              <a:t>Run the gates</a:t>
+            </a:r>
+            <a:endParaRPr lang="en-US" sz="1600" dirty="0"/>
+          </a:p>
+        </p:txBody>
+      </p:sp>
+      <p:sp>
+        <p:nvSpPr>
+          <p:cNvPr id="15" name="Flow text"/>
+          <p:cNvSpPr txBox="1"/>
+          <p:nvPr/>
+        </p:nvSpPr>
+        <p:spPr>
+          <a:xfrm>
+            <a:off x="2858963" y="3867912"/>
+            <a:ext cx="2036003" cy="1554480"/>
+          </a:xfrm>
+          <a:prstGeom prst="rect">
+            <a:avLst/>
+          </a:prstGeom>
+          <a:noFill/>
+          <a:ln/>
+        </p:spPr>
+        <p:txBody>
+          <a:bodyPr wrap="square" lIns="0" tIns="0" rIns="0" bIns="0" rtlCol="0" anchor="t"/>
+          <a:lstStyle/>
+          <a:p>
+            <a:pPr algn="ctr" indent="0" marL="0">
+              <a:buNone/>
+            </a:pPr>
+            <a:r>
+              <a:rPr lang="en-US" sz="1400" dirty="0">
+                <a:solidFill>
+                  <a:schemeClr val="tx2"/>
+                </a:solidFill>
+              </a:rPr>
+              <a:t>Run (R1)–(R4); remove the standby line and rerun (R2): which commitments does the minimal infeasible set name?</a:t>
+            </a:r>
+            <a:endParaRPr lang="en-US" sz="1400" dirty="0"/>
+          </a:p>
+        </p:txBody>
+      </p:sp>
+      <p:sp>
+        <p:nvSpPr>
+          <p:cNvPr id="16" name="Number"/>
           <p:cNvSpPr/>
           <p:nvPr/>
         </p:nvSpPr>
         <p:spPr>
           <a:xfrm>
-            <a:off x="548640" y="3529584"/>
-            <a:ext cx="566928" cy="566928"/>
+            <a:off x="5821528" y="2606040"/>
+            <a:ext cx="548640" cy="548640"/>
           </a:xfrm>
           <a:prstGeom prst="ellipse">
             <a:avLst/>
@@ -13748,14 +13982,14 @@
       </p:sp>
       <p:sp>
         <p:nvSpPr>
-          <p:cNvPr id="12" name="Text 9"/>
+          <p:cNvPr id="17" name="Text 13"/>
           <p:cNvSpPr txBox="1"/>
           <p:nvPr/>
         </p:nvSpPr>
         <p:spPr>
           <a:xfrm>
-            <a:off x="548640" y="3529584"/>
-            <a:ext cx="566928" cy="566928"/>
+            <a:off x="5821528" y="2606040"/>
+            <a:ext cx="548640" cy="548640"/>
           </a:xfrm>
           <a:prstGeom prst="rect">
             <a:avLst/>
@@ -13771,7 +14005,7 @@
               <a:buNone/>
             </a:pPr>
             <a:r>
-              <a:rPr lang="en-US" sz="1500" b="1" dirty="0">
+              <a:rPr lang="en-US" sz="1600" b="1" dirty="0">
                 <a:solidFill>
                   <a:schemeClr val="bg1"/>
                 </a:solidFill>
@@ -13781,56 +14015,95 @@
               </a:rPr>
               <a:t>3</a:t>
             </a:r>
-            <a:endParaRPr lang="en-US" sz="1500" dirty="0"/>
-          </a:p>
-        </p:txBody>
-      </p:sp>
-      <p:sp>
-        <p:nvSpPr>
-          <p:cNvPr id="13" name="Row text"/>
+            <a:endParaRPr lang="en-US" sz="1600" dirty="0"/>
+          </a:p>
+        </p:txBody>
+      </p:sp>
+      <p:sp>
+        <p:nvSpPr>
+          <p:cNvPr id="18" name="Flow head"/>
           <p:cNvSpPr txBox="1"/>
           <p:nvPr/>
         </p:nvSpPr>
         <p:spPr>
           <a:xfrm>
-            <a:off x="1325880" y="3483864"/>
-            <a:ext cx="10317175" cy="841248"/>
-          </a:xfrm>
-          <a:prstGeom prst="rect">
-            <a:avLst/>
-          </a:prstGeom>
-          <a:noFill/>
-          <a:ln/>
-        </p:spPr>
-        <p:txBody>
-          <a:bodyPr wrap="square" lIns="0" tIns="0" rIns="0" bIns="0" rtlCol="0" anchor="ctr"/>
-          <a:lstStyle/>
-          <a:p>
-            <a:pPr indent="0" marL="0">
-              <a:buNone/>
-            </a:pPr>
-            <a:r>
-              <a:rPr lang="en-US" sz="1500" dirty="0">
+            <a:off x="5059558" y="3291840"/>
+            <a:ext cx="2072579" cy="548640"/>
+          </a:xfrm>
+          <a:prstGeom prst="rect">
+            <a:avLst/>
+          </a:prstGeom>
+          <a:noFill/>
+          <a:ln/>
+        </p:spPr>
+        <p:txBody>
+          <a:bodyPr wrap="square" lIns="0" tIns="0" rIns="0" bIns="0" rtlCol="0" anchor="t"/>
+          <a:lstStyle/>
+          <a:p>
+            <a:pPr algn="ctr" indent="0" marL="0">
+              <a:buNone/>
+            </a:pPr>
+            <a:r>
+              <a:rPr lang="en-US" sz="1600" b="1" dirty="0">
                 <a:solidFill>
                   <a:schemeClr val="tx1"/>
                 </a:solidFill>
-              </a:rPr>
-              <a:t>The decision space says how hard the problem is: continuous choices are benign, every lumpy choice doubles the pieces to search, and rules make the search one over functions. A relaxed answer bounds every lumpy one, but rounding it is not a method.</a:t>
-            </a:r>
-            <a:endParaRPr lang="en-US" sz="1500" dirty="0"/>
-          </a:p>
-        </p:txBody>
-      </p:sp>
-      <p:sp>
-        <p:nvSpPr>
-          <p:cNvPr id="14" name="Number"/>
+                <a:latin typeface="Cambria" pitchFamily="34" charset="0"/>
+                <a:ea typeface="Cambria" pitchFamily="34" charset="-122"/>
+                <a:cs typeface="Cambria" pitchFamily="34" charset="-120"/>
+              </a:rPr>
+              <a:t>Explore the decision space</a:t>
+            </a:r>
+            <a:endParaRPr lang="en-US" sz="1600" dirty="0"/>
+          </a:p>
+        </p:txBody>
+      </p:sp>
+      <p:sp>
+        <p:nvSpPr>
+          <p:cNvPr id="19" name="Flow text"/>
+          <p:cNvSpPr txBox="1"/>
+          <p:nvPr/>
+        </p:nvSpPr>
+        <p:spPr>
+          <a:xfrm>
+            <a:off x="5077846" y="3867912"/>
+            <a:ext cx="2036003" cy="1554480"/>
+          </a:xfrm>
+          <a:prstGeom prst="rect">
+            <a:avLst/>
+          </a:prstGeom>
+          <a:noFill/>
+          <a:ln/>
+        </p:spPr>
+        <p:txBody>
+          <a:bodyPr wrap="square" lIns="0" tIns="0" rIns="0" bIns="0" rtlCol="0" anchor="t"/>
+          <a:lstStyle/>
+          <a:p>
+            <a:pPr algn="ctr" indent="0" marL="0">
+              <a:buNone/>
+            </a:pPr>
+            <a:r>
+              <a:rPr lang="en-US" sz="1400" dirty="0">
+                <a:solidFill>
+                  <a:schemeClr val="tx2"/>
+                </a:solidFill>
+              </a:rPr>
+              <a:t>Switch to $50m tranches and whole quarters; count the packages and compare the cheapest with the roundings.</a:t>
+            </a:r>
+            <a:endParaRPr lang="en-US" sz="1400" dirty="0"/>
+          </a:p>
+        </p:txBody>
+      </p:sp>
+      <p:sp>
+        <p:nvSpPr>
+          <p:cNvPr id="20" name="Number"/>
           <p:cNvSpPr/>
           <p:nvPr/>
         </p:nvSpPr>
         <p:spPr>
           <a:xfrm>
-            <a:off x="548640" y="4425696"/>
-            <a:ext cx="566928" cy="566928"/>
+            <a:off x="8040411" y="2606040"/>
+            <a:ext cx="548640" cy="548640"/>
           </a:xfrm>
           <a:prstGeom prst="ellipse">
             <a:avLst/>
@@ -13848,14 +14121,14 @@
       </p:sp>
       <p:sp>
         <p:nvSpPr>
-          <p:cNvPr id="15" name="Text 12"/>
+          <p:cNvPr id="21" name="Text 17"/>
           <p:cNvSpPr txBox="1"/>
           <p:nvPr/>
         </p:nvSpPr>
         <p:spPr>
           <a:xfrm>
-            <a:off x="548640" y="4425696"/>
-            <a:ext cx="566928" cy="566928"/>
+            <a:off x="8040411" y="2606040"/>
+            <a:ext cx="548640" cy="548640"/>
           </a:xfrm>
           <a:prstGeom prst="rect">
             <a:avLst/>
@@ -13871,7 +14144,7 @@
               <a:buNone/>
             </a:pPr>
             <a:r>
-              <a:rPr lang="en-US" sz="1500" b="1" dirty="0">
+              <a:rPr lang="en-US" sz="1600" b="1" dirty="0">
                 <a:solidFill>
                   <a:schemeClr val="bg1"/>
                 </a:solidFill>
@@ -13881,56 +14154,95 @@
               </a:rPr>
               <a:t>4</a:t>
             </a:r>
-            <a:endParaRPr lang="en-US" sz="1500" dirty="0"/>
-          </a:p>
-        </p:txBody>
-      </p:sp>
-      <p:sp>
-        <p:nvSpPr>
-          <p:cNvPr id="16" name="Row text"/>
+            <a:endParaRPr lang="en-US" sz="1600" dirty="0"/>
+          </a:p>
+        </p:txBody>
+      </p:sp>
+      <p:sp>
+        <p:nvSpPr>
+          <p:cNvPr id="22" name="Flow head"/>
           <p:cNvSpPr txBox="1"/>
           <p:nvPr/>
         </p:nvSpPr>
         <p:spPr>
           <a:xfrm>
-            <a:off x="1325880" y="4379976"/>
-            <a:ext cx="10317175" cy="841248"/>
-          </a:xfrm>
-          <a:prstGeom prst="rect">
-            <a:avLst/>
-          </a:prstGeom>
-          <a:noFill/>
-          <a:ln/>
-        </p:spPr>
-        <p:txBody>
-          <a:bodyPr wrap="square" lIns="0" tIns="0" rIns="0" bIns="0" rtlCol="0" anchor="ctr"/>
-          <a:lstStyle/>
-          <a:p>
-            <a:pPr indent="0" marL="0">
-              <a:buNone/>
-            </a:pPr>
-            <a:r>
-              <a:rPr lang="en-US" sz="1500" dirty="0">
+            <a:off x="7278441" y="3291840"/>
+            <a:ext cx="2072579" cy="548640"/>
+          </a:xfrm>
+          <a:prstGeom prst="rect">
+            <a:avLst/>
+          </a:prstGeom>
+          <a:noFill/>
+          <a:ln/>
+        </p:spPr>
+        <p:txBody>
+          <a:bodyPr wrap="square" lIns="0" tIns="0" rIns="0" bIns="0" rtlCol="0" anchor="t"/>
+          <a:lstStyle/>
+          <a:p>
+            <a:pPr algn="ctr" indent="0" marL="0">
+              <a:buNone/>
+            </a:pPr>
+            <a:r>
+              <a:rPr lang="en-US" sz="1600" b="1" dirty="0">
                 <a:solidFill>
                   <a:schemeClr val="tx1"/>
                 </a:solidFill>
-              </a:rPr>
-              <a:t>Rescaling an objective changes no decision; reweighting it can change every decision, so the weights are the board's to declare.</a:t>
-            </a:r>
-            <a:endParaRPr lang="en-US" sz="1500" dirty="0"/>
-          </a:p>
-        </p:txBody>
-      </p:sp>
-      <p:sp>
-        <p:nvSpPr>
-          <p:cNvPr id="17" name="Number"/>
+                <a:latin typeface="Cambria" pitchFamily="34" charset="0"/>
+                <a:ea typeface="Cambria" pitchFamily="34" charset="-122"/>
+                <a:cs typeface="Cambria" pitchFamily="34" charset="-120"/>
+              </a:rPr>
+              <a:t>Rescale, then reweight</a:t>
+            </a:r>
+            <a:endParaRPr lang="en-US" sz="1600" dirty="0"/>
+          </a:p>
+        </p:txBody>
+      </p:sp>
+      <p:sp>
+        <p:nvSpPr>
+          <p:cNvPr id="23" name="Flow text"/>
+          <p:cNvSpPr txBox="1"/>
+          <p:nvPr/>
+        </p:nvSpPr>
+        <p:spPr>
+          <a:xfrm>
+            <a:off x="7296729" y="3867912"/>
+            <a:ext cx="2036003" cy="1554480"/>
+          </a:xfrm>
+          <a:prstGeom prst="rect">
+            <a:avLst/>
+          </a:prstGeom>
+          <a:noFill/>
+          <a:ln/>
+        </p:spPr>
+        <p:txBody>
+          <a:bodyPr wrap="square" lIns="0" tIns="0" rIns="0" bIns="0" rtlCol="0" anchor="t"/>
+          <a:lstStyle/>
+          <a:p>
+            <a:pPr algn="ctr" indent="0" marL="0">
+              <a:buNone/>
+            </a:pPr>
+            <a:r>
+              <a:rPr lang="en-US" sz="1400" dirty="0">
+                <a:solidFill>
+                  <a:schemeClr val="tx2"/>
+                </a:solidFill>
+              </a:rPr>
+              <a:t>State the costs after tax; value a quarter of delay at $4m and $16m.</a:t>
+            </a:r>
+            <a:endParaRPr lang="en-US" sz="1400" dirty="0"/>
+          </a:p>
+        </p:txBody>
+      </p:sp>
+      <p:sp>
+        <p:nvSpPr>
+          <p:cNvPr id="24" name="Number"/>
           <p:cNvSpPr/>
           <p:nvPr/>
         </p:nvSpPr>
         <p:spPr>
           <a:xfrm>
-            <a:off x="548640" y="5321808"/>
-            <a:ext cx="566928" cy="566928"/>
+            <a:off x="10259294" y="2606040"/>
+            <a:ext cx="548640" cy="548640"/>
           </a:xfrm>
           <a:prstGeom prst="ellipse">
             <a:avLst/>
@@ -13948,14 +14260,14 @@
       </p:sp>
       <p:sp>
         <p:nvSpPr>
-          <p:cNvPr id="18" name="Text 15"/>
+          <p:cNvPr id="25" name="Text 21"/>
           <p:cNvSpPr txBox="1"/>
           <p:nvPr/>
         </p:nvSpPr>
         <p:spPr>
           <a:xfrm>
-            <a:off x="548640" y="5321808"/>
-            <a:ext cx="566928" cy="566928"/>
+            <a:off x="10259294" y="2606040"/>
+            <a:ext cx="548640" cy="548640"/>
           </a:xfrm>
           <a:prstGeom prst="rect">
             <a:avLst/>
@@ -13971,7 +14283,7 @@
               <a:buNone/>
             </a:pPr>
             <a:r>
-              <a:rPr lang="en-US" sz="1500" b="1" dirty="0">
+              <a:rPr lang="en-US" sz="1600" b="1" dirty="0">
                 <a:solidFill>
                   <a:schemeClr val="bg1"/>
                 </a:solidFill>
@@ -13981,20 +14293,122 @@
               </a:rPr>
               <a:t>5</a:t>
             </a:r>
-            <a:endParaRPr lang="en-US" sz="1500" dirty="0"/>
-          </a:p>
-        </p:txBody>
-      </p:sp>
-      <p:sp>
-        <p:nvSpPr>
-          <p:cNvPr id="19" name="Row text"/>
+            <a:endParaRPr lang="en-US" sz="1600" dirty="0"/>
+          </a:p>
+        </p:txBody>
+      </p:sp>
+      <p:sp>
+        <p:nvSpPr>
+          <p:cNvPr id="26" name="Flow head"/>
           <p:cNvSpPr txBox="1"/>
           <p:nvPr/>
         </p:nvSpPr>
         <p:spPr>
           <a:xfrm>
-            <a:off x="1325880" y="5276088"/>
-            <a:ext cx="10317175" cy="841248"/>
+            <a:off x="9497324" y="3291840"/>
+            <a:ext cx="2072579" cy="548640"/>
+          </a:xfrm>
+          <a:prstGeom prst="rect">
+            <a:avLst/>
+          </a:prstGeom>
+          <a:noFill/>
+          <a:ln/>
+        </p:spPr>
+        <p:txBody>
+          <a:bodyPr wrap="square" lIns="0" tIns="0" rIns="0" bIns="0" rtlCol="0" anchor="t"/>
+          <a:lstStyle/>
+          <a:p>
+            <a:pPr algn="ctr" indent="0" marL="0">
+              <a:buNone/>
+            </a:pPr>
+            <a:r>
+              <a:rPr lang="en-US" sz="1600" b="1" dirty="0">
+                <a:solidFill>
+                  <a:schemeClr val="tx1"/>
+                </a:solidFill>
+                <a:latin typeface="Cambria" pitchFamily="34" charset="0"/>
+                <a:ea typeface="Cambria" pitchFamily="34" charset="-122"/>
+                <a:cs typeface="Cambria" pitchFamily="34" charset="-120"/>
+              </a:rPr>
+              <a:t>Add a commitment</a:t>
+            </a:r>
+            <a:endParaRPr lang="en-US" sz="1600" dirty="0"/>
+          </a:p>
+        </p:txBody>
+      </p:sp>
+      <p:sp>
+        <p:nvSpPr>
+          <p:cNvPr id="27" name="Flow text"/>
+          <p:cNvSpPr txBox="1"/>
+          <p:nvPr/>
+        </p:nvSpPr>
+        <p:spPr>
+          <a:xfrm>
+            <a:off x="9515612" y="3867912"/>
+            <a:ext cx="2036003" cy="1554480"/>
+          </a:xfrm>
+          <a:prstGeom prst="rect">
+            <a:avLst/>
+          </a:prstGeom>
+          <a:noFill/>
+          <a:ln/>
+        </p:spPr>
+        <p:txBody>
+          <a:bodyPr wrap="square" lIns="0" tIns="0" rIns="0" bIns="0" rtlCol="0" anchor="t"/>
+          <a:lstStyle/>
+          <a:p>
+            <a:pPr algn="ctr" indent="0" marL="0">
+              <a:buNone/>
+            </a:pPr>
+            <a:r>
+              <a:rPr lang="en-US" sz="1400" dirty="0">
+                <a:solidFill>
+                  <a:schemeClr val="tx2"/>
+                </a:solidFill>
+              </a:rPr>
+              <a:t>Add the capability floor and the covenant with the line fully drawn: the feasible packages can only shrink.</a:t>
+            </a:r>
+            <a:endParaRPr lang="en-US" sz="1400" dirty="0"/>
+          </a:p>
+        </p:txBody>
+      </p:sp>
+      <p:sp>
+        <p:nvSpPr>
+          <p:cNvPr id="28" name="Deliverable card"/>
+          <p:cNvSpPr/>
+          <p:nvPr/>
+        </p:nvSpPr>
+        <p:spPr>
+          <a:xfrm>
+            <a:off x="548640" y="5486400"/>
+            <a:ext cx="11094415" cy="685800"/>
+          </a:xfrm>
+          <a:prstGeom prst="roundRect">
+            <a:avLst>
+              <a:gd name="adj" fmla="val 10667"/>
+            </a:avLst>
+          </a:prstGeom>
+          <a:solidFill>
+            <a:schemeClr val="bg2"/>
+          </a:solidFill>
+          <a:ln w="9525">
+            <a:solidFill>
+              <a:srgbClr val="C4CBD8"/>
+            </a:solidFill>
+            <a:prstDash val="solid"/>
+          </a:ln>
+        </p:spPr>
+      </p:sp>
+      <p:sp>
+        <p:nvSpPr>
+          <p:cNvPr id="29" name="Deliverable"/>
+          <p:cNvSpPr txBox="1"/>
+          <p:nvPr/>
+        </p:nvSpPr>
+        <p:spPr>
+          <a:xfrm>
+            <a:off x="777240" y="5559552"/>
+            <a:ext cx="10637215" cy="539496"/>
           </a:xfrm>
           <a:prstGeom prst="rect">
             <a:avLst/>
@@ -14010,14 +14424,22 @@
               <a:buNone/>
             </a:pPr>
             <a:r>
-              <a:rPr lang="en-US" sz="1500" dirty="0">
+              <a:rPr lang="en-US" sz="1400" b="1" dirty="0">
                 <a:solidFill>
                   <a:schemeClr val="tx1"/>
                 </a:solidFill>
               </a:rPr>
-              <a:t>An answer is worth its certificates, and certificates are about the company only when the readiness gates have passed.</a:t>
-            </a:r>
-            <a:endParaRPr lang="en-US" sz="1500" dirty="0"/>
+              <a:t>Deliverable:</a:t>
+            </a:r>
+            <a:r>
+              <a:rPr lang="en-US" sz="1400" dirty="0">
+                <a:solidFill>
+                  <a:schemeClr val="tx1"/>
+                </a:solidFill>
+              </a:rPr>
+              <a:t> a one-page note to the board: the package to sign, its odds and cost, what the lumps cost, which declaration moves the answer most, and the certificates that support each number. About 60 minutes.</a:t>
+            </a:r>
+            <a:endParaRPr lang="en-US" sz="1400" dirty="0"/>
           </a:p>
         </p:txBody>
       </p:sp>
@@ -14123,7 +14545,7 @@
                   <a:schemeClr val="accent1"/>
                 </a:solidFill>
               </a:rPr>
-              <a:t>THIS WEEK'S LABORATORY</a:t>
+              <a:t>KEY TAKEAWAYS</a:t>
             </a:r>
             <a:endParaRPr lang="en-US" sz="1200" dirty="0"/>
           </a:p>
@@ -14164,7 +14586,7 @@
                 <a:ea typeface="Cambria" pitchFamily="34" charset="-122"/>
                 <a:cs typeface="Cambria" pitchFamily="34" charset="-120"/>
               </a:rPr>
-              <a:t>Notebook and workbook reproduce the book</a:t>
+              <a:t>What to carry forward</a:t>
             </a:r>
             <a:endParaRPr lang="en-US" sz="3200" dirty="0"/>
           </a:p>
@@ -14172,26 +14594,24 @@
       </p:sp>
       <p:sp>
         <p:nvSpPr>
-          <p:cNvPr id="5" name="Stat card"/>
+          <p:cNvPr id="5" name="Number"/>
           <p:cNvSpPr/>
           <p:nvPr/>
         </p:nvSpPr>
         <p:spPr>
           <a:xfrm>
-            <a:off x="548640" y="1691640"/>
-            <a:ext cx="2567864" cy="1691640"/>
-          </a:xfrm>
-          <a:prstGeom prst="roundRect">
-            <a:avLst>
-              <a:gd name="adj" fmla="val 4324"/>
-            </a:avLst>
+            <a:off x="548640" y="1737360"/>
+            <a:ext cx="566928" cy="566928"/>
+          </a:xfrm>
+          <a:prstGeom prst="ellipse">
+            <a:avLst/>
           </a:prstGeom>
           <a:solidFill>
-            <a:schemeClr val="tx1"/>
+            <a:schemeClr val="accent1"/>
           </a:solidFill>
-          <a:ln w="9525">
+          <a:ln w="6350">
             <a:solidFill>
-              <a:srgbClr val="0F1E3D"/>
+              <a:schemeClr val="accent1"/>
             </a:solidFill>
             <a:prstDash val="solid"/>
           </a:ln>
@@ -14199,14 +14619,14 @@
       </p:sp>
       <p:sp>
         <p:nvSpPr>
-          <p:cNvPr id="6" name="Stat value"/>
+          <p:cNvPr id="6" name="Text 3"/>
           <p:cNvSpPr txBox="1"/>
           <p:nvPr/>
         </p:nvSpPr>
         <p:spPr>
           <a:xfrm>
-            <a:off x="685800" y="1801368"/>
-            <a:ext cx="2293544" cy="914400"/>
+            <a:off x="548640" y="1737360"/>
+            <a:ext cx="566928" cy="566928"/>
           </a:xfrm>
           <a:prstGeom prst="rect">
             <a:avLst/>
@@ -14222,78 +14642,76 @@
               <a:buNone/>
             </a:pPr>
             <a:r>
-              <a:rPr lang="en-US" sz="4400" b="1" dirty="0">
-                <a:solidFill>
-                  <a:schemeClr val="accent1"/>
-                </a:solidFill>
-                <a:latin typeface="Cambria" pitchFamily="34" charset="0"/>
-                <a:ea typeface="Cambria" pitchFamily="34" charset="-122"/>
-                <a:cs typeface="Cambria" pitchFamily="34" charset="-120"/>
-              </a:rPr>
-              <a:t>45</a:t>
-            </a:r>
-            <a:endParaRPr lang="en-US" sz="4400" dirty="0"/>
-          </a:p>
-        </p:txBody>
-      </p:sp>
-      <p:sp>
-        <p:nvSpPr>
-          <p:cNvPr id="7" name="Stat label"/>
+              <a:rPr lang="en-US" sz="1500" b="1" dirty="0">
+                <a:solidFill>
+                  <a:schemeClr val="bg1"/>
+                </a:solidFill>
+                <a:latin typeface="Calibri" pitchFamily="34" charset="0"/>
+                <a:ea typeface="Calibri" pitchFamily="34" charset="-122"/>
+                <a:cs typeface="Calibri" pitchFamily="34" charset="-120"/>
+              </a:rPr>
+              <a:t>1</a:t>
+            </a:r>
+            <a:endParaRPr lang="en-US" sz="1500" dirty="0"/>
+          </a:p>
+        </p:txBody>
+      </p:sp>
+      <p:sp>
+        <p:nvSpPr>
+          <p:cNvPr id="7" name="Row text"/>
           <p:cNvSpPr txBox="1"/>
           <p:nvPr/>
         </p:nvSpPr>
         <p:spPr>
           <a:xfrm>
-            <a:off x="685800" y="2697480"/>
-            <a:ext cx="2293544" cy="612648"/>
-          </a:xfrm>
-          <a:prstGeom prst="rect">
-            <a:avLst/>
-          </a:prstGeom>
-          <a:noFill/>
-          <a:ln/>
-        </p:spPr>
-        <p:txBody>
-          <a:bodyPr wrap="square" lIns="0" tIns="0" rIns="0" bIns="0" rtlCol="0" anchor="t"/>
-          <a:lstStyle/>
-          <a:p>
-            <a:pPr algn="ctr" indent="0" marL="0">
-              <a:buNone/>
-            </a:pPr>
-            <a:r>
-              <a:rPr lang="en-US" sz="1400" dirty="0">
-                <a:solidFill>
-                  <a:schemeClr val="bg2"/>
-                </a:solidFill>
-              </a:rPr>
-              <a:t>notebook checkpoints, every one PASS</a:t>
-            </a:r>
-            <a:endParaRPr lang="en-US" sz="1400" dirty="0"/>
-          </a:p>
-        </p:txBody>
-      </p:sp>
-      <p:sp>
-        <p:nvSpPr>
-          <p:cNvPr id="8" name="Stat card"/>
+            <a:off x="1325880" y="1691640"/>
+            <a:ext cx="10317175" cy="841248"/>
+          </a:xfrm>
+          <a:prstGeom prst="rect">
+            <a:avLst/>
+          </a:prstGeom>
+          <a:noFill/>
+          <a:ln/>
+        </p:spPr>
+        <p:txBody>
+          <a:bodyPr wrap="square" lIns="0" tIns="0" rIns="0" bIns="0" rtlCol="0" anchor="ctr"/>
+          <a:lstStyle/>
+          <a:p>
+            <a:pPr indent="0" marL="0">
+              <a:buNone/>
+            </a:pPr>
+            <a:r>
+              <a:rPr lang="en-US" sz="1500" dirty="0">
+                <a:solidFill>
+                  <a:schemeClr val="tx1"/>
+                </a:solidFill>
+              </a:rPr>
+              <a:t>Analysis runs forward from a plan to its consequences; optimization runs backward from what the company wants and must respect to a plan. Both use the same declared model, and optimization needs every term of its problem declared.</a:t>
+            </a:r>
+            <a:endParaRPr lang="en-US" sz="1500" dirty="0"/>
+          </a:p>
+        </p:txBody>
+      </p:sp>
+      <p:sp>
+        <p:nvSpPr>
+          <p:cNvPr id="8" name="Number"/>
           <p:cNvSpPr/>
           <p:nvPr/>
         </p:nvSpPr>
         <p:spPr>
           <a:xfrm>
-            <a:off x="3390824" y="1691640"/>
-            <a:ext cx="2567864" cy="1691640"/>
-          </a:xfrm>
-          <a:prstGeom prst="roundRect">
-            <a:avLst>
-              <a:gd name="adj" fmla="val 4324"/>
-            </a:avLst>
+            <a:off x="548640" y="2633472"/>
+            <a:ext cx="566928" cy="566928"/>
+          </a:xfrm>
+          <a:prstGeom prst="ellipse">
+            <a:avLst/>
           </a:prstGeom>
           <a:solidFill>
-            <a:schemeClr val="bg2"/>
+            <a:schemeClr val="accent1"/>
           </a:solidFill>
-          <a:ln w="9525">
+          <a:ln w="6350">
             <a:solidFill>
-              <a:srgbClr val="C4CBD8"/>
+              <a:schemeClr val="accent1"/>
             </a:solidFill>
             <a:prstDash val="solid"/>
           </a:ln>
@@ -14301,14 +14719,14 @@
       </p:sp>
       <p:sp>
         <p:nvSpPr>
-          <p:cNvPr id="9" name="Stat value"/>
+          <p:cNvPr id="9" name="Text 6"/>
           <p:cNvSpPr txBox="1"/>
           <p:nvPr/>
         </p:nvSpPr>
         <p:spPr>
           <a:xfrm>
-            <a:off x="3527984" y="1801368"/>
-            <a:ext cx="2293544" cy="914400"/>
+            <a:off x="548640" y="2633472"/>
+            <a:ext cx="566928" cy="566928"/>
           </a:xfrm>
           <a:prstGeom prst="rect">
             <a:avLst/>
@@ -14324,78 +14742,76 @@
               <a:buNone/>
             </a:pPr>
             <a:r>
-              <a:rPr lang="en-US" sz="4400" b="1" dirty="0">
+              <a:rPr lang="en-US" sz="1500" b="1" dirty="0">
+                <a:solidFill>
+                  <a:schemeClr val="bg1"/>
+                </a:solidFill>
+                <a:latin typeface="Calibri" pitchFamily="34" charset="0"/>
+                <a:ea typeface="Calibri" pitchFamily="34" charset="-122"/>
+                <a:cs typeface="Calibri" pitchFamily="34" charset="-120"/>
+              </a:rPr>
+              <a:t>2</a:t>
+            </a:r>
+            <a:endParaRPr lang="en-US" sz="1500" dirty="0"/>
+          </a:p>
+        </p:txBody>
+      </p:sp>
+      <p:sp>
+        <p:nvSpPr>
+          <p:cNvPr id="10" name="Row text"/>
+          <p:cNvSpPr txBox="1"/>
+          <p:nvPr/>
+        </p:nvSpPr>
+        <p:spPr>
+          <a:xfrm>
+            <a:off x="1325880" y="2587752"/>
+            <a:ext cx="10317175" cy="841248"/>
+          </a:xfrm>
+          <a:prstGeom prst="rect">
+            <a:avLst/>
+          </a:prstGeom>
+          <a:noFill/>
+          <a:ln/>
+        </p:spPr>
+        <p:txBody>
+          <a:bodyPr wrap="square" lIns="0" tIns="0" rIns="0" bIns="0" rtlCol="0" anchor="ctr"/>
+          <a:lstStyle/>
+          <a:p>
+            <a:pPr indent="0" marL="0">
+              <a:buNone/>
+            </a:pPr>
+            <a:r>
+              <a:rPr lang="en-US" sz="1500" dirty="0">
                 <a:solidFill>
                   <a:schemeClr val="tx1"/>
                 </a:solidFill>
-                <a:latin typeface="Cambria" pitchFamily="34" charset="0"/>
-                <a:ea typeface="Cambria" pitchFamily="34" charset="-122"/>
-                <a:cs typeface="Cambria" pitchFamily="34" charset="-120"/>
-              </a:rPr>
-              <a:t>53</a:t>
-            </a:r>
-            <a:endParaRPr lang="en-US" sz="4400" dirty="0"/>
-          </a:p>
-        </p:txBody>
-      </p:sp>
-      <p:sp>
-        <p:nvSpPr>
-          <p:cNvPr id="10" name="Stat label"/>
-          <p:cNvSpPr txBox="1"/>
-          <p:nvPr/>
-        </p:nvSpPr>
-        <p:spPr>
-          <a:xfrm>
-            <a:off x="3527984" y="2697480"/>
-            <a:ext cx="2293544" cy="612648"/>
-          </a:xfrm>
-          <a:prstGeom prst="rect">
-            <a:avLst/>
-          </a:prstGeom>
-          <a:noFill/>
-          <a:ln/>
-        </p:spPr>
-        <p:txBody>
-          <a:bodyPr wrap="square" lIns="0" tIns="0" rIns="0" bIns="0" rtlCol="0" anchor="t"/>
-          <a:lstStyle/>
-          <a:p>
-            <a:pPr algn="ctr" indent="0" marL="0">
-              <a:buNone/>
-            </a:pPr>
-            <a:r>
-              <a:rPr lang="en-US" sz="1400" dirty="0">
-                <a:solidFill>
-                  <a:schemeClr val="tx2"/>
-                </a:solidFill>
-              </a:rPr>
-              <a:t>workbook checks against the engine, ALL PASS</a:t>
-            </a:r>
-            <a:endParaRPr lang="en-US" sz="1400" dirty="0"/>
-          </a:p>
-        </p:txBody>
-      </p:sp>
-      <p:sp>
-        <p:nvSpPr>
-          <p:cNvPr id="11" name="Stat card"/>
+              </a:rPr>
+              <a:t>Every well-posed transformation decision fits one canonical form: decisions, an objective, commitments, and the company's dynamics, with nothing lost and nothing left to taste.</a:t>
+            </a:r>
+            <a:endParaRPr lang="en-US" sz="1500" dirty="0"/>
+          </a:p>
+        </p:txBody>
+      </p:sp>
+      <p:sp>
+        <p:nvSpPr>
+          <p:cNvPr id="11" name="Number"/>
           <p:cNvSpPr/>
           <p:nvPr/>
         </p:nvSpPr>
         <p:spPr>
           <a:xfrm>
-            <a:off x="6233008" y="1691640"/>
-            <a:ext cx="2567864" cy="1691640"/>
-          </a:xfrm>
-          <a:prstGeom prst="roundRect">
-            <a:avLst>
-              <a:gd name="adj" fmla="val 4324"/>
-            </a:avLst>
+            <a:off x="548640" y="3529584"/>
+            <a:ext cx="566928" cy="566928"/>
+          </a:xfrm>
+          <a:prstGeom prst="ellipse">
+            <a:avLst/>
           </a:prstGeom>
           <a:solidFill>
-            <a:schemeClr val="bg2"/>
+            <a:schemeClr val="accent1"/>
           </a:solidFill>
-          <a:ln w="9525">
+          <a:ln w="6350">
             <a:solidFill>
-              <a:srgbClr val="C4CBD8"/>
+              <a:schemeClr val="accent1"/>
             </a:solidFill>
             <a:prstDash val="solid"/>
           </a:ln>
@@ -14403,14 +14819,14 @@
       </p:sp>
       <p:sp>
         <p:nvSpPr>
-          <p:cNvPr id="12" name="Stat value"/>
+          <p:cNvPr id="12" name="Text 9"/>
           <p:cNvSpPr txBox="1"/>
           <p:nvPr/>
         </p:nvSpPr>
         <p:spPr>
           <a:xfrm>
-            <a:off x="6370168" y="1801368"/>
-            <a:ext cx="2293544" cy="914400"/>
+            <a:off x="548640" y="3529584"/>
+            <a:ext cx="566928" cy="566928"/>
           </a:xfrm>
           <a:prstGeom prst="rect">
             <a:avLst/>
@@ -14426,78 +14842,76 @@
               <a:buNone/>
             </a:pPr>
             <a:r>
-              <a:rPr lang="en-US" sz="4400" b="1" dirty="0">
+              <a:rPr lang="en-US" sz="1500" b="1" dirty="0">
+                <a:solidFill>
+                  <a:schemeClr val="bg1"/>
+                </a:solidFill>
+                <a:latin typeface="Calibri" pitchFamily="34" charset="0"/>
+                <a:ea typeface="Calibri" pitchFamily="34" charset="-122"/>
+                <a:cs typeface="Calibri" pitchFamily="34" charset="-120"/>
+              </a:rPr>
+              <a:t>3</a:t>
+            </a:r>
+            <a:endParaRPr lang="en-US" sz="1500" dirty="0"/>
+          </a:p>
+        </p:txBody>
+      </p:sp>
+      <p:sp>
+        <p:nvSpPr>
+          <p:cNvPr id="13" name="Row text"/>
+          <p:cNvSpPr txBox="1"/>
+          <p:nvPr/>
+        </p:nvSpPr>
+        <p:spPr>
+          <a:xfrm>
+            <a:off x="1325880" y="3483864"/>
+            <a:ext cx="10317175" cy="841248"/>
+          </a:xfrm>
+          <a:prstGeom prst="rect">
+            <a:avLst/>
+          </a:prstGeom>
+          <a:noFill/>
+          <a:ln/>
+        </p:spPr>
+        <p:txBody>
+          <a:bodyPr wrap="square" lIns="0" tIns="0" rIns="0" bIns="0" rtlCol="0" anchor="ctr"/>
+          <a:lstStyle/>
+          <a:p>
+            <a:pPr indent="0" marL="0">
+              <a:buNone/>
+            </a:pPr>
+            <a:r>
+              <a:rPr lang="en-US" sz="1500" dirty="0">
                 <a:solidFill>
                   <a:schemeClr val="tx1"/>
                 </a:solidFill>
-                <a:latin typeface="Cambria" pitchFamily="34" charset="0"/>
-                <a:ea typeface="Cambria" pitchFamily="34" charset="-122"/>
-                <a:cs typeface="Cambria" pitchFamily="34" charset="-120"/>
-              </a:rPr>
-              <a:t>26201</a:t>
-            </a:r>
-            <a:endParaRPr lang="en-US" sz="4400" dirty="0"/>
-          </a:p>
-        </p:txBody>
-      </p:sp>
-      <p:sp>
-        <p:nvSpPr>
-          <p:cNvPr id="13" name="Stat label"/>
-          <p:cNvSpPr txBox="1"/>
-          <p:nvPr/>
-        </p:nvSpPr>
-        <p:spPr>
-          <a:xfrm>
-            <a:off x="6370168" y="2697480"/>
-            <a:ext cx="2293544" cy="612648"/>
-          </a:xfrm>
-          <a:prstGeom prst="rect">
-            <a:avLst/>
-          </a:prstGeom>
-          <a:noFill/>
-          <a:ln/>
-        </p:spPr>
-        <p:txBody>
-          <a:bodyPr wrap="square" lIns="0" tIns="0" rIns="0" bIns="0" rtlCol="0" anchor="t"/>
-          <a:lstStyle/>
-          <a:p>
-            <a:pPr algn="ctr" indent="0" marL="0">
-              <a:buNone/>
-            </a:pPr>
-            <a:r>
-              <a:rPr lang="en-US" sz="1400" dirty="0">
-                <a:solidFill>
-                  <a:schemeClr val="tx2"/>
-                </a:solidFill>
-              </a:rPr>
-              <a:t>the lab's seed</a:t>
-            </a:r>
-            <a:endParaRPr lang="en-US" sz="1400" dirty="0"/>
-          </a:p>
-        </p:txBody>
-      </p:sp>
-      <p:sp>
-        <p:nvSpPr>
-          <p:cNvPr id="14" name="Stat card"/>
+              </a:rPr>
+              <a:t>The decision space says how hard the problem is: continuous choices are benign, every lumpy choice doubles the pieces to search, and rules make the search one over functions. A relaxed answer bounds every lumpy one, but rounding it is not a method.</a:t>
+            </a:r>
+            <a:endParaRPr lang="en-US" sz="1500" dirty="0"/>
+          </a:p>
+        </p:txBody>
+      </p:sp>
+      <p:sp>
+        <p:nvSpPr>
+          <p:cNvPr id="14" name="Number"/>
           <p:cNvSpPr/>
           <p:nvPr/>
         </p:nvSpPr>
         <p:spPr>
           <a:xfrm>
-            <a:off x="9075191" y="1691640"/>
-            <a:ext cx="2567864" cy="1691640"/>
-          </a:xfrm>
-          <a:prstGeom prst="roundRect">
-            <a:avLst>
-              <a:gd name="adj" fmla="val 4324"/>
-            </a:avLst>
+            <a:off x="548640" y="4425696"/>
+            <a:ext cx="566928" cy="566928"/>
+          </a:xfrm>
+          <a:prstGeom prst="ellipse">
+            <a:avLst/>
           </a:prstGeom>
           <a:solidFill>
-            <a:schemeClr val="bg2"/>
+            <a:schemeClr val="accent1"/>
           </a:solidFill>
-          <a:ln w="9525">
+          <a:ln w="6350">
             <a:solidFill>
-              <a:srgbClr val="C4CBD8"/>
+              <a:schemeClr val="accent1"/>
             </a:solidFill>
             <a:prstDash val="solid"/>
           </a:ln>
@@ -14505,14 +14919,14 @@
       </p:sp>
       <p:sp>
         <p:nvSpPr>
-          <p:cNvPr id="15" name="Stat value"/>
+          <p:cNvPr id="15" name="Text 12"/>
           <p:cNvSpPr txBox="1"/>
           <p:nvPr/>
         </p:nvSpPr>
         <p:spPr>
           <a:xfrm>
-            <a:off x="9212351" y="1801368"/>
-            <a:ext cx="2293544" cy="914400"/>
+            <a:off x="548640" y="4425696"/>
+            <a:ext cx="566928" cy="566928"/>
           </a:xfrm>
           <a:prstGeom prst="rect">
             <a:avLst/>
@@ -14528,145 +14942,153 @@
               <a:buNone/>
             </a:pPr>
             <a:r>
-              <a:rPr lang="en-US" sz="3000" b="1" dirty="0">
+              <a:rPr lang="en-US" sz="1500" b="1" dirty="0">
+                <a:solidFill>
+                  <a:schemeClr val="bg1"/>
+                </a:solidFill>
+                <a:latin typeface="Calibri" pitchFamily="34" charset="0"/>
+                <a:ea typeface="Calibri" pitchFamily="34" charset="-122"/>
+                <a:cs typeface="Calibri" pitchFamily="34" charset="-120"/>
+              </a:rPr>
+              <a:t>4</a:t>
+            </a:r>
+            <a:endParaRPr lang="en-US" sz="1500" dirty="0"/>
+          </a:p>
+        </p:txBody>
+      </p:sp>
+      <p:sp>
+        <p:nvSpPr>
+          <p:cNvPr id="16" name="Row text"/>
+          <p:cNvSpPr txBox="1"/>
+          <p:nvPr/>
+        </p:nvSpPr>
+        <p:spPr>
+          <a:xfrm>
+            <a:off x="1325880" y="4379976"/>
+            <a:ext cx="10317175" cy="841248"/>
+          </a:xfrm>
+          <a:prstGeom prst="rect">
+            <a:avLst/>
+          </a:prstGeom>
+          <a:noFill/>
+          <a:ln/>
+        </p:spPr>
+        <p:txBody>
+          <a:bodyPr wrap="square" lIns="0" tIns="0" rIns="0" bIns="0" rtlCol="0" anchor="ctr"/>
+          <a:lstStyle/>
+          <a:p>
+            <a:pPr indent="0" marL="0">
+              <a:buNone/>
+            </a:pPr>
+            <a:r>
+              <a:rPr lang="en-US" sz="1500" dirty="0">
                 <a:solidFill>
                   <a:schemeClr val="tx1"/>
                 </a:solidFill>
-                <a:latin typeface="Cambria" pitchFamily="34" charset="0"/>
-                <a:ea typeface="Cambria" pitchFamily="34" charset="-122"/>
-                <a:cs typeface="Cambria" pitchFamily="34" charset="-120"/>
-              </a:rPr>
-              <a:t>AXIOM-01</a:t>
-            </a:r>
-            <a:endParaRPr lang="en-US" sz="3000" dirty="0"/>
-          </a:p>
-        </p:txBody>
-      </p:sp>
-      <p:sp>
-        <p:nvSpPr>
-          <p:cNvPr id="16" name="Stat label"/>
+              </a:rPr>
+              <a:t>Rescaling an objective changes no decision; reweighting it can change every decision, so the weights are the board's to declare.</a:t>
+            </a:r>
+            <a:endParaRPr lang="en-US" sz="1500" dirty="0"/>
+          </a:p>
+        </p:txBody>
+      </p:sp>
+      <p:sp>
+        <p:nvSpPr>
+          <p:cNvPr id="17" name="Number"/>
+          <p:cNvSpPr/>
+          <p:nvPr/>
+        </p:nvSpPr>
+        <p:spPr>
+          <a:xfrm>
+            <a:off x="548640" y="5321808"/>
+            <a:ext cx="566928" cy="566928"/>
+          </a:xfrm>
+          <a:prstGeom prst="ellipse">
+            <a:avLst/>
+          </a:prstGeom>
+          <a:solidFill>
+            <a:schemeClr val="accent1"/>
+          </a:solidFill>
+          <a:ln w="6350">
+            <a:solidFill>
+              <a:schemeClr val="accent1"/>
+            </a:solidFill>
+            <a:prstDash val="solid"/>
+          </a:ln>
+        </p:spPr>
+      </p:sp>
+      <p:sp>
+        <p:nvSpPr>
+          <p:cNvPr id="18" name="Text 15"/>
           <p:cNvSpPr txBox="1"/>
           <p:nvPr/>
         </p:nvSpPr>
         <p:spPr>
           <a:xfrm>
-            <a:off x="9212351" y="2697480"/>
-            <a:ext cx="2293544" cy="612648"/>
-          </a:xfrm>
-          <a:prstGeom prst="rect">
-            <a:avLst/>
-          </a:prstGeom>
-          <a:noFill/>
-          <a:ln/>
-        </p:spPr>
-        <p:txBody>
-          <a:bodyPr wrap="square" lIns="0" tIns="0" rIns="0" bIns="0" rtlCol="0" anchor="t"/>
+            <a:off x="548640" y="5321808"/>
+            <a:ext cx="566928" cy="566928"/>
+          </a:xfrm>
+          <a:prstGeom prst="rect">
+            <a:avLst/>
+          </a:prstGeom>
+          <a:noFill/>
+          <a:ln/>
+        </p:spPr>
+        <p:txBody>
+          <a:bodyPr wrap="square" lIns="0" tIns="0" rIns="0" bIns="0" rtlCol="0" anchor="ctr"/>
           <a:lstStyle/>
           <a:p>
             <a:pPr algn="ctr" indent="0" marL="0">
               <a:buNone/>
             </a:pPr>
             <a:r>
-              <a:rPr lang="en-US" sz="1400" dirty="0">
-                <a:solidFill>
-                  <a:schemeClr val="tx2"/>
-                </a:solidFill>
-              </a:rPr>
-              <a:t>AXIOM Lab 2.1</a:t>
-            </a:r>
-            <a:endParaRPr lang="en-US" sz="1400" dirty="0"/>
-          </a:p>
-        </p:txBody>
-      </p:sp>
-      <p:sp>
-        <p:nvSpPr>
-          <p:cNvPr id="17" name="Bullets"/>
+              <a:rPr lang="en-US" sz="1500" b="1" dirty="0">
+                <a:solidFill>
+                  <a:schemeClr val="bg1"/>
+                </a:solidFill>
+                <a:latin typeface="Calibri" pitchFamily="34" charset="0"/>
+                <a:ea typeface="Calibri" pitchFamily="34" charset="-122"/>
+                <a:cs typeface="Calibri" pitchFamily="34" charset="-120"/>
+              </a:rPr>
+              <a:t>5</a:t>
+            </a:r>
+            <a:endParaRPr lang="en-US" sz="1500" dirty="0"/>
+          </a:p>
+        </p:txBody>
+      </p:sp>
+      <p:sp>
+        <p:nvSpPr>
+          <p:cNvPr id="19" name="Row text"/>
           <p:cNvSpPr txBox="1"/>
           <p:nvPr/>
         </p:nvSpPr>
         <p:spPr>
           <a:xfrm>
-            <a:off x="548640" y="3703320"/>
-            <a:ext cx="11094415" cy="2468880"/>
-          </a:xfrm>
-          <a:prstGeom prst="rect">
-            <a:avLst/>
-          </a:prstGeom>
-          <a:noFill/>
-          <a:ln/>
-        </p:spPr>
-        <p:txBody>
-          <a:bodyPr wrap="square" lIns="635" tIns="635" rIns="635" bIns="635" rtlCol="0" anchor="t"/>
-          <a:lstStyle/>
-          <a:p>
-            <a:pPr marL="228600" indent="-228600">
-              <a:spcAft>
-                <a:spcPts val="800"/>
-              </a:spcAft>
-              <a:buSzPct val="100000"/>
-              <a:buChar char="•"/>
-            </a:pPr>
-            <a:r>
-              <a:rPr lang="en-US" sz="1700" b="1" dirty="0">
+            <a:off x="1325880" y="5276088"/>
+            <a:ext cx="10317175" cy="841248"/>
+          </a:xfrm>
+          <a:prstGeom prst="rect">
+            <a:avLst/>
+          </a:prstGeom>
+          <a:noFill/>
+          <a:ln/>
+        </p:spPr>
+        <p:txBody>
+          <a:bodyPr wrap="square" lIns="0" tIns="0" rIns="0" bIns="0" rtlCol="0" anchor="ctr"/>
+          <a:lstStyle/>
+          <a:p>
+            <a:pPr indent="0" marL="0">
+              <a:buNone/>
+            </a:pPr>
+            <a:r>
+              <a:rPr lang="en-US" sz="1500" dirty="0">
                 <a:solidFill>
                   <a:schemeClr val="tx1"/>
                 </a:solidFill>
               </a:rPr>
-              <a:t>Notebook</a:t>
-            </a:r>
-            <a:r>
-              <a:rPr lang="en-US" sz="1700" dirty="0">
-                <a:solidFill>
-                  <a:schemeClr val="tx1"/>
-                </a:solidFill>
-              </a:rPr>
-              <a:t> DCT_V2_Ch01_Lab.ipynb: Worked Example 1.1 and the lab's five steps in eight panels, on the book's 100,000 paths, ready for Colab</a:t>
-            </a:r>
-            <a:endParaRPr lang="en-US" sz="1700" dirty="0"/>
-          </a:p>
-          <a:p>
-            <a:pPr marL="228600" indent="-228600">
-              <a:spcAft>
-                <a:spcPts val="800"/>
-              </a:spcAft>
-              <a:buSzPct val="100000"/>
-              <a:buChar char="•"/>
-            </a:pPr>
-            <a:r>
-              <a:rPr lang="en-US" sz="1700" b="1" dirty="0">
-                <a:solidFill>
-                  <a:schemeClr val="tx1"/>
-                </a:solidFill>
-              </a:rPr>
-              <a:t>Workbook</a:t>
-            </a:r>
-            <a:r>
-              <a:rPr lang="en-US" sz="1700" dirty="0">
-                <a:solidFill>
-                  <a:schemeClr val="tx1"/>
-                </a:solidFill>
-              </a:rPr>
-              <a:t> DCT_V2_Ch01_Lab.xlsx: the formulation assistant, the gates, the 63 packages, Table 1.3, reweighting and the two-channel budget, in formulas</a:t>
-            </a:r>
-            <a:endParaRPr lang="en-US" sz="1700" dirty="0"/>
-          </a:p>
-          <a:p>
-            <a:pPr marL="228600" indent="-228600">
-              <a:spcAft>
-                <a:spcPts val="800"/>
-              </a:spcAft>
-              <a:buSzPct val="100000"/>
-              <a:buChar char="•"/>
-            </a:pPr>
-            <a:r>
-              <a:rPr lang="en-US" sz="1700" dirty="0">
-                <a:solidFill>
-                  <a:schemeClr val="tx1"/>
-                </a:solidFill>
-              </a:rPr>
-              <a:t>Every number on these slides is the book's, and both companions check it</a:t>
-            </a:r>
-            <a:endParaRPr lang="en-US" sz="1700" dirty="0"/>
+              <a:t>An answer is worth its certificates, and certificates are about the company only when the readiness gates have passed.</a:t>
+            </a:r>
+            <a:endParaRPr lang="en-US" sz="1500" dirty="0"/>
           </a:p>
         </p:txBody>
       </p:sp>
@@ -14772,6 +15194,655 @@
                   <a:schemeClr val="accent1"/>
                 </a:solidFill>
               </a:rPr>
+              <a:t>THIS WEEK'S LABORATORY</a:t>
+            </a:r>
+            <a:endParaRPr lang="en-US" sz="1200" dirty="0"/>
+          </a:p>
+        </p:txBody>
+      </p:sp>
+      <p:sp>
+        <p:nvSpPr>
+          <p:cNvPr id="4" name="Text 1"/>
+          <p:cNvSpPr/>
+          <p:nvPr>
+            <p:ph idx="103" type="title" hasCustomPrompt="1"/>
+          </p:nvPr>
+        </p:nvSpPr>
+        <p:spPr>
+          <a:xfrm>
+            <a:off x="548640" y="658368"/>
+            <a:ext cx="11094415" cy="868680"/>
+          </a:xfrm>
+          <a:prstGeom prst="rect">
+            <a:avLst/>
+          </a:prstGeom>
+          <a:noFill/>
+          <a:ln/>
+        </p:spPr>
+        <p:txBody>
+          <a:bodyPr wrap="square" lIns="0" tIns="0" rIns="0" bIns="0" rtlCol="0" anchor="t"/>
+          <a:lstStyle/>
+          <a:p>
+            <a:pPr algn="l" indent="0" marL="0">
+              <a:buNone/>
+            </a:pPr>
+            <a:r>
+              <a:rPr lang="en-US" sz="3200" b="1" dirty="0">
+                <a:solidFill>
+                  <a:schemeClr val="tx1"/>
+                </a:solidFill>
+                <a:latin typeface="Cambria" pitchFamily="34" charset="0"/>
+                <a:ea typeface="Cambria" pitchFamily="34" charset="-122"/>
+                <a:cs typeface="Cambria" pitchFamily="34" charset="-120"/>
+              </a:rPr>
+              <a:t>Notebook and workbook reproduce the book</a:t>
+            </a:r>
+            <a:endParaRPr lang="en-US" sz="3200" dirty="0"/>
+          </a:p>
+        </p:txBody>
+      </p:sp>
+      <p:sp>
+        <p:nvSpPr>
+          <p:cNvPr id="5" name="Stat card"/>
+          <p:cNvSpPr/>
+          <p:nvPr/>
+        </p:nvSpPr>
+        <p:spPr>
+          <a:xfrm>
+            <a:off x="548640" y="1691640"/>
+            <a:ext cx="2567864" cy="1691640"/>
+          </a:xfrm>
+          <a:prstGeom prst="roundRect">
+            <a:avLst>
+              <a:gd name="adj" fmla="val 4324"/>
+            </a:avLst>
+          </a:prstGeom>
+          <a:solidFill>
+            <a:schemeClr val="tx1"/>
+          </a:solidFill>
+          <a:ln w="9525">
+            <a:solidFill>
+              <a:srgbClr val="0F1E3D"/>
+            </a:solidFill>
+            <a:prstDash val="solid"/>
+          </a:ln>
+        </p:spPr>
+      </p:sp>
+      <p:sp>
+        <p:nvSpPr>
+          <p:cNvPr id="6" name="Stat value"/>
+          <p:cNvSpPr txBox="1"/>
+          <p:nvPr/>
+        </p:nvSpPr>
+        <p:spPr>
+          <a:xfrm>
+            <a:off x="685800" y="1801368"/>
+            <a:ext cx="2293544" cy="914400"/>
+          </a:xfrm>
+          <a:prstGeom prst="rect">
+            <a:avLst/>
+          </a:prstGeom>
+          <a:noFill/>
+          <a:ln/>
+        </p:spPr>
+        <p:txBody>
+          <a:bodyPr wrap="square" lIns="0" tIns="0" rIns="0" bIns="0" rtlCol="0" anchor="ctr"/>
+          <a:lstStyle/>
+          <a:p>
+            <a:pPr algn="ctr" indent="0" marL="0">
+              <a:buNone/>
+            </a:pPr>
+            <a:r>
+              <a:rPr lang="en-US" sz="4400" b="1" dirty="0">
+                <a:solidFill>
+                  <a:schemeClr val="accent1"/>
+                </a:solidFill>
+                <a:latin typeface="Cambria" pitchFamily="34" charset="0"/>
+                <a:ea typeface="Cambria" pitchFamily="34" charset="-122"/>
+                <a:cs typeface="Cambria" pitchFamily="34" charset="-120"/>
+              </a:rPr>
+              <a:t>45</a:t>
+            </a:r>
+            <a:endParaRPr lang="en-US" sz="4400" dirty="0"/>
+          </a:p>
+        </p:txBody>
+      </p:sp>
+      <p:sp>
+        <p:nvSpPr>
+          <p:cNvPr id="7" name="Stat label"/>
+          <p:cNvSpPr txBox="1"/>
+          <p:nvPr/>
+        </p:nvSpPr>
+        <p:spPr>
+          <a:xfrm>
+            <a:off x="685800" y="2697480"/>
+            <a:ext cx="2293544" cy="612648"/>
+          </a:xfrm>
+          <a:prstGeom prst="rect">
+            <a:avLst/>
+          </a:prstGeom>
+          <a:noFill/>
+          <a:ln/>
+        </p:spPr>
+        <p:txBody>
+          <a:bodyPr wrap="square" lIns="0" tIns="0" rIns="0" bIns="0" rtlCol="0" anchor="t"/>
+          <a:lstStyle/>
+          <a:p>
+            <a:pPr algn="ctr" indent="0" marL="0">
+              <a:buNone/>
+            </a:pPr>
+            <a:r>
+              <a:rPr lang="en-US" sz="1400" dirty="0">
+                <a:solidFill>
+                  <a:schemeClr val="bg2"/>
+                </a:solidFill>
+              </a:rPr>
+              <a:t>notebook checkpoints, every one PASS</a:t>
+            </a:r>
+            <a:endParaRPr lang="en-US" sz="1400" dirty="0"/>
+          </a:p>
+        </p:txBody>
+      </p:sp>
+      <p:sp>
+        <p:nvSpPr>
+          <p:cNvPr id="8" name="Stat card"/>
+          <p:cNvSpPr/>
+          <p:nvPr/>
+        </p:nvSpPr>
+        <p:spPr>
+          <a:xfrm>
+            <a:off x="3390824" y="1691640"/>
+            <a:ext cx="2567864" cy="1691640"/>
+          </a:xfrm>
+          <a:prstGeom prst="roundRect">
+            <a:avLst>
+              <a:gd name="adj" fmla="val 4324"/>
+            </a:avLst>
+          </a:prstGeom>
+          <a:solidFill>
+            <a:schemeClr val="bg2"/>
+          </a:solidFill>
+          <a:ln w="9525">
+            <a:solidFill>
+              <a:srgbClr val="C4CBD8"/>
+            </a:solidFill>
+            <a:prstDash val="solid"/>
+          </a:ln>
+        </p:spPr>
+      </p:sp>
+      <p:sp>
+        <p:nvSpPr>
+          <p:cNvPr id="9" name="Stat value"/>
+          <p:cNvSpPr txBox="1"/>
+          <p:nvPr/>
+        </p:nvSpPr>
+        <p:spPr>
+          <a:xfrm>
+            <a:off x="3527984" y="1801368"/>
+            <a:ext cx="2293544" cy="914400"/>
+          </a:xfrm>
+          <a:prstGeom prst="rect">
+            <a:avLst/>
+          </a:prstGeom>
+          <a:noFill/>
+          <a:ln/>
+        </p:spPr>
+        <p:txBody>
+          <a:bodyPr wrap="square" lIns="0" tIns="0" rIns="0" bIns="0" rtlCol="0" anchor="ctr"/>
+          <a:lstStyle/>
+          <a:p>
+            <a:pPr algn="ctr" indent="0" marL="0">
+              <a:buNone/>
+            </a:pPr>
+            <a:r>
+              <a:rPr lang="en-US" sz="4400" b="1" dirty="0">
+                <a:solidFill>
+                  <a:schemeClr val="tx1"/>
+                </a:solidFill>
+                <a:latin typeface="Cambria" pitchFamily="34" charset="0"/>
+                <a:ea typeface="Cambria" pitchFamily="34" charset="-122"/>
+                <a:cs typeface="Cambria" pitchFamily="34" charset="-120"/>
+              </a:rPr>
+              <a:t>53</a:t>
+            </a:r>
+            <a:endParaRPr lang="en-US" sz="4400" dirty="0"/>
+          </a:p>
+        </p:txBody>
+      </p:sp>
+      <p:sp>
+        <p:nvSpPr>
+          <p:cNvPr id="10" name="Stat label"/>
+          <p:cNvSpPr txBox="1"/>
+          <p:nvPr/>
+        </p:nvSpPr>
+        <p:spPr>
+          <a:xfrm>
+            <a:off x="3527984" y="2697480"/>
+            <a:ext cx="2293544" cy="612648"/>
+          </a:xfrm>
+          <a:prstGeom prst="rect">
+            <a:avLst/>
+          </a:prstGeom>
+          <a:noFill/>
+          <a:ln/>
+        </p:spPr>
+        <p:txBody>
+          <a:bodyPr wrap="square" lIns="0" tIns="0" rIns="0" bIns="0" rtlCol="0" anchor="t"/>
+          <a:lstStyle/>
+          <a:p>
+            <a:pPr algn="ctr" indent="0" marL="0">
+              <a:buNone/>
+            </a:pPr>
+            <a:r>
+              <a:rPr lang="en-US" sz="1400" dirty="0">
+                <a:solidFill>
+                  <a:schemeClr val="tx2"/>
+                </a:solidFill>
+              </a:rPr>
+              <a:t>workbook checks against the engine, ALL PASS</a:t>
+            </a:r>
+            <a:endParaRPr lang="en-US" sz="1400" dirty="0"/>
+          </a:p>
+        </p:txBody>
+      </p:sp>
+      <p:sp>
+        <p:nvSpPr>
+          <p:cNvPr id="11" name="Stat card"/>
+          <p:cNvSpPr/>
+          <p:nvPr/>
+        </p:nvSpPr>
+        <p:spPr>
+          <a:xfrm>
+            <a:off x="6233008" y="1691640"/>
+            <a:ext cx="2567864" cy="1691640"/>
+          </a:xfrm>
+          <a:prstGeom prst="roundRect">
+            <a:avLst>
+              <a:gd name="adj" fmla="val 4324"/>
+            </a:avLst>
+          </a:prstGeom>
+          <a:solidFill>
+            <a:schemeClr val="bg2"/>
+          </a:solidFill>
+          <a:ln w="9525">
+            <a:solidFill>
+              <a:srgbClr val="C4CBD8"/>
+            </a:solidFill>
+            <a:prstDash val="solid"/>
+          </a:ln>
+        </p:spPr>
+      </p:sp>
+      <p:sp>
+        <p:nvSpPr>
+          <p:cNvPr id="12" name="Stat value"/>
+          <p:cNvSpPr txBox="1"/>
+          <p:nvPr/>
+        </p:nvSpPr>
+        <p:spPr>
+          <a:xfrm>
+            <a:off x="6370168" y="1801368"/>
+            <a:ext cx="2293544" cy="914400"/>
+          </a:xfrm>
+          <a:prstGeom prst="rect">
+            <a:avLst/>
+          </a:prstGeom>
+          <a:noFill/>
+          <a:ln/>
+        </p:spPr>
+        <p:txBody>
+          <a:bodyPr wrap="square" lIns="0" tIns="0" rIns="0" bIns="0" rtlCol="0" anchor="ctr"/>
+          <a:lstStyle/>
+          <a:p>
+            <a:pPr algn="ctr" indent="0" marL="0">
+              <a:buNone/>
+            </a:pPr>
+            <a:r>
+              <a:rPr lang="en-US" sz="4400" b="1" dirty="0">
+                <a:solidFill>
+                  <a:schemeClr val="tx1"/>
+                </a:solidFill>
+                <a:latin typeface="Cambria" pitchFamily="34" charset="0"/>
+                <a:ea typeface="Cambria" pitchFamily="34" charset="-122"/>
+                <a:cs typeface="Cambria" pitchFamily="34" charset="-120"/>
+              </a:rPr>
+              <a:t>26201</a:t>
+            </a:r>
+            <a:endParaRPr lang="en-US" sz="4400" dirty="0"/>
+          </a:p>
+        </p:txBody>
+      </p:sp>
+      <p:sp>
+        <p:nvSpPr>
+          <p:cNvPr id="13" name="Stat label"/>
+          <p:cNvSpPr txBox="1"/>
+          <p:nvPr/>
+        </p:nvSpPr>
+        <p:spPr>
+          <a:xfrm>
+            <a:off x="6370168" y="2697480"/>
+            <a:ext cx="2293544" cy="612648"/>
+          </a:xfrm>
+          <a:prstGeom prst="rect">
+            <a:avLst/>
+          </a:prstGeom>
+          <a:noFill/>
+          <a:ln/>
+        </p:spPr>
+        <p:txBody>
+          <a:bodyPr wrap="square" lIns="0" tIns="0" rIns="0" bIns="0" rtlCol="0" anchor="t"/>
+          <a:lstStyle/>
+          <a:p>
+            <a:pPr algn="ctr" indent="0" marL="0">
+              <a:buNone/>
+            </a:pPr>
+            <a:r>
+              <a:rPr lang="en-US" sz="1400" dirty="0">
+                <a:solidFill>
+                  <a:schemeClr val="tx2"/>
+                </a:solidFill>
+              </a:rPr>
+              <a:t>the lab's seed</a:t>
+            </a:r>
+            <a:endParaRPr lang="en-US" sz="1400" dirty="0"/>
+          </a:p>
+        </p:txBody>
+      </p:sp>
+      <p:sp>
+        <p:nvSpPr>
+          <p:cNvPr id="14" name="Stat card"/>
+          <p:cNvSpPr/>
+          <p:nvPr/>
+        </p:nvSpPr>
+        <p:spPr>
+          <a:xfrm>
+            <a:off x="9075191" y="1691640"/>
+            <a:ext cx="2567864" cy="1691640"/>
+          </a:xfrm>
+          <a:prstGeom prst="roundRect">
+            <a:avLst>
+              <a:gd name="adj" fmla="val 4324"/>
+            </a:avLst>
+          </a:prstGeom>
+          <a:solidFill>
+            <a:schemeClr val="bg2"/>
+          </a:solidFill>
+          <a:ln w="9525">
+            <a:solidFill>
+              <a:srgbClr val="C4CBD8"/>
+            </a:solidFill>
+            <a:prstDash val="solid"/>
+          </a:ln>
+        </p:spPr>
+      </p:sp>
+      <p:sp>
+        <p:nvSpPr>
+          <p:cNvPr id="15" name="Stat value"/>
+          <p:cNvSpPr txBox="1"/>
+          <p:nvPr/>
+        </p:nvSpPr>
+        <p:spPr>
+          <a:xfrm>
+            <a:off x="9212351" y="1801368"/>
+            <a:ext cx="2293544" cy="914400"/>
+          </a:xfrm>
+          <a:prstGeom prst="rect">
+            <a:avLst/>
+          </a:prstGeom>
+          <a:noFill/>
+          <a:ln/>
+        </p:spPr>
+        <p:txBody>
+          <a:bodyPr wrap="square" lIns="0" tIns="0" rIns="0" bIns="0" rtlCol="0" anchor="ctr"/>
+          <a:lstStyle/>
+          <a:p>
+            <a:pPr algn="ctr" indent="0" marL="0">
+              <a:buNone/>
+            </a:pPr>
+            <a:r>
+              <a:rPr lang="en-US" sz="3000" b="1" dirty="0">
+                <a:solidFill>
+                  <a:schemeClr val="tx1"/>
+                </a:solidFill>
+                <a:latin typeface="Cambria" pitchFamily="34" charset="0"/>
+                <a:ea typeface="Cambria" pitchFamily="34" charset="-122"/>
+                <a:cs typeface="Cambria" pitchFamily="34" charset="-120"/>
+              </a:rPr>
+              <a:t>AXIOM-01</a:t>
+            </a:r>
+            <a:endParaRPr lang="en-US" sz="3000" dirty="0"/>
+          </a:p>
+        </p:txBody>
+      </p:sp>
+      <p:sp>
+        <p:nvSpPr>
+          <p:cNvPr id="16" name="Stat label"/>
+          <p:cNvSpPr txBox="1"/>
+          <p:nvPr/>
+        </p:nvSpPr>
+        <p:spPr>
+          <a:xfrm>
+            <a:off x="9212351" y="2697480"/>
+            <a:ext cx="2293544" cy="612648"/>
+          </a:xfrm>
+          <a:prstGeom prst="rect">
+            <a:avLst/>
+          </a:prstGeom>
+          <a:noFill/>
+          <a:ln/>
+        </p:spPr>
+        <p:txBody>
+          <a:bodyPr wrap="square" lIns="0" tIns="0" rIns="0" bIns="0" rtlCol="0" anchor="t"/>
+          <a:lstStyle/>
+          <a:p>
+            <a:pPr algn="ctr" indent="0" marL="0">
+              <a:buNone/>
+            </a:pPr>
+            <a:r>
+              <a:rPr lang="en-US" sz="1400" dirty="0">
+                <a:solidFill>
+                  <a:schemeClr val="tx2"/>
+                </a:solidFill>
+              </a:rPr>
+              <a:t>AXIOM Lab 2.1</a:t>
+            </a:r>
+            <a:endParaRPr lang="en-US" sz="1400" dirty="0"/>
+          </a:p>
+        </p:txBody>
+      </p:sp>
+      <p:sp>
+        <p:nvSpPr>
+          <p:cNvPr id="17" name="Bullets"/>
+          <p:cNvSpPr txBox="1"/>
+          <p:nvPr/>
+        </p:nvSpPr>
+        <p:spPr>
+          <a:xfrm>
+            <a:off x="548640" y="3703320"/>
+            <a:ext cx="11094415" cy="2468880"/>
+          </a:xfrm>
+          <a:prstGeom prst="rect">
+            <a:avLst/>
+          </a:prstGeom>
+          <a:noFill/>
+          <a:ln/>
+        </p:spPr>
+        <p:txBody>
+          <a:bodyPr wrap="square" lIns="635" tIns="635" rIns="635" bIns="635" rtlCol="0" anchor="t"/>
+          <a:lstStyle/>
+          <a:p>
+            <a:pPr marL="228600" indent="-228600">
+              <a:spcAft>
+                <a:spcPts val="800"/>
+              </a:spcAft>
+              <a:buSzPct val="100000"/>
+              <a:buChar char="•"/>
+            </a:pPr>
+            <a:r>
+              <a:rPr lang="en-US" sz="1700" b="1" dirty="0">
+                <a:solidFill>
+                  <a:schemeClr val="tx1"/>
+                </a:solidFill>
+              </a:rPr>
+              <a:t>Notebook</a:t>
+            </a:r>
+            <a:r>
+              <a:rPr lang="en-US" sz="1700" dirty="0">
+                <a:solidFill>
+                  <a:schemeClr val="tx1"/>
+                </a:solidFill>
+              </a:rPr>
+              <a:t> DCT_V2_Ch01_Lab.ipynb: Worked Example 1.1 and the lab's five steps in eight panels, on the book's 100,000 paths, ready for Colab</a:t>
+            </a:r>
+            <a:endParaRPr lang="en-US" sz="1700" dirty="0"/>
+          </a:p>
+          <a:p>
+            <a:pPr marL="228600" indent="-228600">
+              <a:spcAft>
+                <a:spcPts val="800"/>
+              </a:spcAft>
+              <a:buSzPct val="100000"/>
+              <a:buChar char="•"/>
+            </a:pPr>
+            <a:r>
+              <a:rPr lang="en-US" sz="1700" b="1" dirty="0">
+                <a:solidFill>
+                  <a:schemeClr val="tx1"/>
+                </a:solidFill>
+              </a:rPr>
+              <a:t>Workbook</a:t>
+            </a:r>
+            <a:r>
+              <a:rPr lang="en-US" sz="1700" dirty="0">
+                <a:solidFill>
+                  <a:schemeClr val="tx1"/>
+                </a:solidFill>
+              </a:rPr>
+              <a:t> DCT_V2_Ch01_Lab.xlsx: the formulation assistant, the gates, the 63 packages, Table 1.3, reweighting and the two-channel budget, in formulas</a:t>
+            </a:r>
+            <a:endParaRPr lang="en-US" sz="1700" dirty="0"/>
+          </a:p>
+          <a:p>
+            <a:pPr marL="228600" indent="-228600">
+              <a:spcAft>
+                <a:spcPts val="800"/>
+              </a:spcAft>
+              <a:buSzPct val="100000"/>
+              <a:buChar char="•"/>
+            </a:pPr>
+            <a:r>
+              <a:rPr lang="en-US" sz="1700" dirty="0">
+                <a:solidFill>
+                  <a:schemeClr val="tx1"/>
+                </a:solidFill>
+              </a:rPr>
+              <a:t>Every number on these slides is the book's, and both companions check it</a:t>
+            </a:r>
+            <a:endParaRPr lang="en-US" sz="1700" dirty="0"/>
+          </a:p>
+        </p:txBody>
+      </p:sp>
+      <p:sp>
+        <p:nvSpPr>
+          <p:cNvPr id="25" name="Slide Number Placeholder 0"/>
+          <p:cNvSpPr>
+            <a:spLocks noGrp="1"/>
+          </p:cNvSpPr>
+          <p:nvPr>
+            <p:ph type="sldNum" sz="quarter" idx="4294967295"/>
+          </p:nvPr>
+        </p:nvSpPr>
+        <p:spPr>
+          <a:xfrm>
+            <a:off x="11094415" y="6382512"/>
+            <a:ext cx="548640" cy="237744"/>
+          </a:xfrm>
+          <a:prstGeom prst="rect">
+            <a:avLst/>
+          </a:prstGeom>
+          <a:extLst>
+            <a:ext uri="{C572A759-6A51-4108-AA02-DFA0A04FC94B}">
+              <ma14:wrappingTextBoxFlag xmlns:ma14="http://schemas.microsoft.com/office/mac/drawingml/2011/main" val="0"/>
+            </a:ext>
+          </a:extLst>
+        </p:spPr>
+        <p:txBody>
+          <a:bodyPr/>
+          <a:lstStyle>
+            <a:lvl1pPr>
+              <a:defRPr sz="1000">
+                <a:solidFill>
+                  <a:srgbClr val="5A6B82"/>
+                </a:solidFill>
+              </a:defRPr>
+            </a:lvl1pPr>
+          </a:lstStyle>
+          <a:p>
+            <a:pPr algn="r"/>
+            <a:fld id="{F7021451-1387-4CA6-816F-3879F97B5CBC}" type="slidenum">
+              <a:rPr b="0" lang="en-US"/>
+              <a:t>24</a:t>
+            </a:fld>
+            <a:endParaRPr lang="en-US"/>
+          </a:p>
+        </p:txBody>
+      </p:sp>
+    </p:spTree>
+  </p:cSld>
+  <p:clrMapOvr>
+    <a:masterClrMapping/>
+  </p:clrMapOvr>
+</p:sld>
+</file>
+
+<file path=ppt/slides/slide25.xml><?xml version="1.0" encoding="utf-8"?>
+<p:sld xmlns:a="http://schemas.openxmlformats.org/drawingml/2006/main" xmlns:r="http://schemas.openxmlformats.org/officeDocument/2006/relationships" xmlns:p="http://schemas.openxmlformats.org/presentationml/2006/main">
+  <p:cSld name="Slide 25">
+    <p:spTree>
+      <p:nvGrpSpPr>
+        <p:cNvPr id="1" name=""/>
+        <p:cNvGrpSpPr/>
+        <p:nvPr/>
+      </p:nvGrpSpPr>
+      <p:grpSpPr>
+        <a:xfrm>
+          <a:off x="0" y="0"/>
+          <a:ext cx="0" cy="0"/>
+          <a:chOff x="0" y="0"/>
+          <a:chExt cx="0" cy="0"/>
+        </a:xfrm>
+      </p:grpSpPr>
+      <p:sp>
+        <p:nvSpPr>
+          <p:cNvPr id="3" name="Text 1"/>
+          <p:cNvSpPr/>
+          <p:nvPr>
+            <p:ph idx="102" type="body" hasCustomPrompt="1"/>
+          </p:nvPr>
+        </p:nvSpPr>
+        <p:spPr>
+          <a:xfrm>
+            <a:off x="548640" y="347472"/>
+            <a:ext cx="11094415" cy="292608"/>
+          </a:xfrm>
+          <a:prstGeom prst="rect">
+            <a:avLst/>
+          </a:prstGeom>
+          <a:noFill/>
+          <a:ln/>
+        </p:spPr>
+        <p:txBody>
+          <a:bodyPr wrap="square" lIns="0" tIns="0" rIns="0" bIns="0" rtlCol="0"/>
+          <a:lstStyle/>
+          <a:p>
+            <a:pPr indent="0" marL="0">
+              <a:buNone/>
+            </a:pPr>
+            <a:r>
+              <a:rPr lang="en-US" sz="1200" b="1" spc="200" kern="0" dirty="0">
+                <a:solidFill>
+                  <a:schemeClr val="accent1"/>
+                </a:solidFill>
+              </a:rPr>
               <a:t>NEXT · CHAPTER 2</a:t>
             </a:r>
             <a:endParaRPr lang="en-US" sz="1200" dirty="0"/>
@@ -14976,7 +16047,7 @@
             <a:pPr algn="r"/>
             <a:fld id="{F7021451-1387-4CA6-816F-3879F97B5CBC}" type="slidenum">
               <a:rPr b="0" lang="en-US"/>
-              <a:t>24</a:t>
+              <a:t>25</a:t>
             </a:fld>
             <a:endParaRPr lang="en-US"/>
           </a:p>
@@ -15729,7 +16800,7 @@
                 <a:ea typeface="Cambria" pitchFamily="34" charset="-122"/>
                 <a:cs typeface="Cambria" pitchFamily="34" charset="-120"/>
               </a:rPr>
-              <a:t>Eight sections, a worked example and a lab</a:t>
+              <a:t>Eight sections, a worked example, a case and a lab</a:t>
             </a:r>
             <a:endParaRPr lang="en-US" sz="3200" dirty="0"/>
           </a:p>
@@ -15744,11 +16815,11 @@
         <p:spPr>
           <a:xfrm>
             <a:off x="548640" y="1691640"/>
-            <a:ext cx="1999427" cy="2103120"/>
+            <a:ext cx="1999427" cy="1310640"/>
           </a:xfrm>
           <a:prstGeom prst="roundRect">
             <a:avLst>
-              <a:gd name="adj" fmla="val 3659"/>
+              <a:gd name="adj" fmla="val 5581"/>
             </a:avLst>
           </a:prstGeom>
           <a:solidFill>
@@ -15807,7 +16878,7 @@
         <p:spPr>
           <a:xfrm>
             <a:off x="731520" y="2148840"/>
-            <a:ext cx="1633667" cy="1444752"/>
+            <a:ext cx="1633667" cy="652272"/>
           </a:xfrm>
           <a:prstGeom prst="rect">
             <a:avLst/>
@@ -15846,11 +16917,11 @@
         <p:spPr>
           <a:xfrm>
             <a:off x="2822387" y="1691640"/>
-            <a:ext cx="1999427" cy="2103120"/>
+            <a:ext cx="1999427" cy="1310640"/>
           </a:xfrm>
           <a:prstGeom prst="roundRect">
             <a:avLst>
-              <a:gd name="adj" fmla="val 3659"/>
+              <a:gd name="adj" fmla="val 5581"/>
             </a:avLst>
           </a:prstGeom>
           <a:solidFill>
@@ -15909,7 +16980,7 @@
         <p:spPr>
           <a:xfrm>
             <a:off x="3005267" y="2148840"/>
-            <a:ext cx="1633667" cy="1444752"/>
+            <a:ext cx="1633667" cy="652272"/>
           </a:xfrm>
           <a:prstGeom prst="rect">
             <a:avLst/>
@@ -15948,11 +17019,11 @@
         <p:spPr>
           <a:xfrm>
             <a:off x="5096134" y="1691640"/>
-            <a:ext cx="1999427" cy="2103120"/>
+            <a:ext cx="1999427" cy="1310640"/>
           </a:xfrm>
           <a:prstGeom prst="roundRect">
             <a:avLst>
-              <a:gd name="adj" fmla="val 3659"/>
+              <a:gd name="adj" fmla="val 5581"/>
             </a:avLst>
           </a:prstGeom>
           <a:solidFill>
@@ -16011,7 +17082,7 @@
         <p:spPr>
           <a:xfrm>
             <a:off x="5279014" y="2148840"/>
-            <a:ext cx="1633667" cy="1444752"/>
+            <a:ext cx="1633667" cy="652272"/>
           </a:xfrm>
           <a:prstGeom prst="rect">
             <a:avLst/>
@@ -16050,11 +17121,11 @@
         <p:spPr>
           <a:xfrm>
             <a:off x="7369881" y="1691640"/>
-            <a:ext cx="1999427" cy="2103120"/>
+            <a:ext cx="1999427" cy="1310640"/>
           </a:xfrm>
           <a:prstGeom prst="roundRect">
             <a:avLst>
-              <a:gd name="adj" fmla="val 3659"/>
+              <a:gd name="adj" fmla="val 5581"/>
             </a:avLst>
           </a:prstGeom>
           <a:solidFill>
@@ -16113,7 +17184,7 @@
         <p:spPr>
           <a:xfrm>
             <a:off x="7552761" y="2148840"/>
-            <a:ext cx="1633667" cy="1444752"/>
+            <a:ext cx="1633667" cy="652272"/>
           </a:xfrm>
           <a:prstGeom prst="rect">
             <a:avLst/>
@@ -16152,11 +17223,11 @@
         <p:spPr>
           <a:xfrm>
             <a:off x="9643628" y="1691640"/>
-            <a:ext cx="1999427" cy="2103120"/>
+            <a:ext cx="1999427" cy="1310640"/>
           </a:xfrm>
           <a:prstGeom prst="roundRect">
             <a:avLst>
-              <a:gd name="adj" fmla="val 3659"/>
+              <a:gd name="adj" fmla="val 5581"/>
             </a:avLst>
           </a:prstGeom>
           <a:solidFill>
@@ -16215,7 +17286,7 @@
         <p:spPr>
           <a:xfrm>
             <a:off x="9826508" y="2148840"/>
-            <a:ext cx="1633667" cy="1444752"/>
+            <a:ext cx="1633667" cy="652272"/>
           </a:xfrm>
           <a:prstGeom prst="rect">
             <a:avLst/>
@@ -16253,12 +17324,12 @@
         </p:nvSpPr>
         <p:spPr>
           <a:xfrm>
-            <a:off x="548640" y="4069080"/>
-            <a:ext cx="1999427" cy="2103120"/>
+            <a:off x="548640" y="3276600"/>
+            <a:ext cx="1999427" cy="1310640"/>
           </a:xfrm>
           <a:prstGeom prst="roundRect">
             <a:avLst>
-              <a:gd name="adj" fmla="val 3659"/>
+              <a:gd name="adj" fmla="val 5581"/>
             </a:avLst>
           </a:prstGeom>
           <a:solidFill>
@@ -16280,7 +17351,7 @@
         </p:nvSpPr>
         <p:spPr>
           <a:xfrm>
-            <a:off x="731520" y="4197096"/>
+            <a:off x="731520" y="3404616"/>
             <a:ext cx="1633667" cy="310896"/>
           </a:xfrm>
           <a:prstGeom prst="rect">
@@ -16316,8 +17387,8 @@
         </p:nvSpPr>
         <p:spPr>
           <a:xfrm>
-            <a:off x="731520" y="4526280"/>
-            <a:ext cx="1633667" cy="1444752"/>
+            <a:off x="731520" y="3733800"/>
+            <a:ext cx="1633667" cy="652272"/>
           </a:xfrm>
           <a:prstGeom prst="rect">
             <a:avLst/>
@@ -16355,12 +17426,12 @@
         </p:nvSpPr>
         <p:spPr>
           <a:xfrm>
-            <a:off x="2822387" y="4069080"/>
-            <a:ext cx="1999427" cy="2103120"/>
+            <a:off x="2822387" y="3276600"/>
+            <a:ext cx="1999427" cy="1310640"/>
           </a:xfrm>
           <a:prstGeom prst="roundRect">
             <a:avLst>
-              <a:gd name="adj" fmla="val 3659"/>
+              <a:gd name="adj" fmla="val 5581"/>
             </a:avLst>
           </a:prstGeom>
           <a:solidFill>
@@ -16382,7 +17453,7 @@
         </p:nvSpPr>
         <p:spPr>
           <a:xfrm>
-            <a:off x="3005267" y="4197096"/>
+            <a:off x="3005267" y="3404616"/>
             <a:ext cx="1633667" cy="310896"/>
           </a:xfrm>
           <a:prstGeom prst="rect">
@@ -16418,8 +17489,8 @@
         </p:nvSpPr>
         <p:spPr>
           <a:xfrm>
-            <a:off x="3005267" y="4526280"/>
-            <a:ext cx="1633667" cy="1444752"/>
+            <a:off x="3005267" y="3733800"/>
+            <a:ext cx="1633667" cy="652272"/>
           </a:xfrm>
           <a:prstGeom prst="rect">
             <a:avLst/>
@@ -16457,12 +17528,12 @@
         </p:nvSpPr>
         <p:spPr>
           <a:xfrm>
-            <a:off x="5096134" y="4069080"/>
-            <a:ext cx="1999427" cy="2103120"/>
+            <a:off x="5096134" y="3276600"/>
+            <a:ext cx="1999427" cy="1310640"/>
           </a:xfrm>
           <a:prstGeom prst="roundRect">
             <a:avLst>
-              <a:gd name="adj" fmla="val 3659"/>
+              <a:gd name="adj" fmla="val 5581"/>
             </a:avLst>
           </a:prstGeom>
           <a:solidFill>
@@ -16484,7 +17555,7 @@
         </p:nvSpPr>
         <p:spPr>
           <a:xfrm>
-            <a:off x="5279014" y="4197096"/>
+            <a:off x="5279014" y="3404616"/>
             <a:ext cx="1633667" cy="310896"/>
           </a:xfrm>
           <a:prstGeom prst="rect">
@@ -16520,8 +17591,8 @@
         </p:nvSpPr>
         <p:spPr>
           <a:xfrm>
-            <a:off x="5279014" y="4526280"/>
-            <a:ext cx="1633667" cy="1444752"/>
+            <a:off x="5279014" y="3733800"/>
+            <a:ext cx="1633667" cy="652272"/>
           </a:xfrm>
           <a:prstGeom prst="rect">
             <a:avLst/>
@@ -16559,12 +17630,12 @@
         </p:nvSpPr>
         <p:spPr>
           <a:xfrm>
-            <a:off x="7369881" y="4069080"/>
-            <a:ext cx="1999427" cy="2103120"/>
+            <a:off x="7369881" y="3276600"/>
+            <a:ext cx="1999427" cy="1310640"/>
           </a:xfrm>
           <a:prstGeom prst="roundRect">
             <a:avLst>
-              <a:gd name="adj" fmla="val 3659"/>
+              <a:gd name="adj" fmla="val 5581"/>
             </a:avLst>
           </a:prstGeom>
           <a:solidFill>
@@ -16586,7 +17657,7 @@
         </p:nvSpPr>
         <p:spPr>
           <a:xfrm>
-            <a:off x="7552761" y="4197096"/>
+            <a:off x="7552761" y="3404616"/>
             <a:ext cx="1633667" cy="310896"/>
           </a:xfrm>
           <a:prstGeom prst="rect">
@@ -16622,8 +17693,8 @@
         </p:nvSpPr>
         <p:spPr>
           <a:xfrm>
-            <a:off x="7552761" y="4526280"/>
-            <a:ext cx="1633667" cy="1444752"/>
+            <a:off x="7552761" y="3733800"/>
+            <a:ext cx="1633667" cy="652272"/>
           </a:xfrm>
           <a:prstGeom prst="rect">
             <a:avLst/>
@@ -16661,12 +17732,12 @@
         </p:nvSpPr>
         <p:spPr>
           <a:xfrm>
-            <a:off x="9643628" y="4069080"/>
-            <a:ext cx="1999427" cy="2103120"/>
+            <a:off x="9643628" y="3276600"/>
+            <a:ext cx="1999427" cy="1310640"/>
           </a:xfrm>
           <a:prstGeom prst="roundRect">
             <a:avLst>
-              <a:gd name="adj" fmla="val 3659"/>
+              <a:gd name="adj" fmla="val 5581"/>
             </a:avLst>
           </a:prstGeom>
           <a:solidFill>
@@ -16688,7 +17759,7 @@
         </p:nvSpPr>
         <p:spPr>
           <a:xfrm>
-            <a:off x="9826508" y="4197096"/>
+            <a:off x="9826508" y="3404616"/>
             <a:ext cx="1633667" cy="310896"/>
           </a:xfrm>
           <a:prstGeom prst="rect">
@@ -16710,7 +17781,7 @@
                   <a:schemeClr val="accent1"/>
                 </a:solidFill>
               </a:rPr>
-              <a:t>AXIOM Lab 2.1</a:t>
+              <a:t>In Practice</a:t>
             </a:r>
             <a:endParaRPr lang="en-US" sz="1300" dirty="0"/>
           </a:p>
@@ -16724,8 +17795,110 @@
         </p:nvSpPr>
         <p:spPr>
           <a:xfrm>
-            <a:off x="9826508" y="4526280"/>
-            <a:ext cx="1633667" cy="1444752"/>
+            <a:off x="9826508" y="3733800"/>
+            <a:ext cx="1633667" cy="652272"/>
+          </a:xfrm>
+          <a:prstGeom prst="rect">
+            <a:avLst/>
+          </a:prstGeom>
+          <a:noFill/>
+          <a:ln/>
+        </p:spPr>
+        <p:txBody>
+          <a:bodyPr wrap="square" lIns="0" tIns="0" rIns="0" bIns="0" rtlCol="0" anchor="t"/>
+          <a:lstStyle/>
+          <a:p>
+            <a:pPr indent="0" marL="0">
+              <a:buNone/>
+            </a:pPr>
+            <a:r>
+              <a:rPr lang="en-US" sz="1300" b="1" dirty="0">
+                <a:solidFill>
+                  <a:schemeClr val="tx1"/>
+                </a:solidFill>
+                <a:latin typeface="Cambria" pitchFamily="34" charset="0"/>
+                <a:ea typeface="Cambria" pitchFamily="34" charset="-122"/>
+                <a:cs typeface="Cambria" pitchFamily="34" charset="-120"/>
+              </a:rPr>
+              <a:t>UPS Routes Fifty-Five Thousand Drivers a Day</a:t>
+            </a:r>
+            <a:endParaRPr lang="en-US" sz="1300" dirty="0"/>
+          </a:p>
+        </p:txBody>
+      </p:sp>
+      <p:sp>
+        <p:nvSpPr>
+          <p:cNvPr id="35" name="Card"/>
+          <p:cNvSpPr/>
+          <p:nvPr/>
+        </p:nvSpPr>
+        <p:spPr>
+          <a:xfrm>
+            <a:off x="548640" y="4861560"/>
+            <a:ext cx="1999427" cy="1310640"/>
+          </a:xfrm>
+          <a:prstGeom prst="roundRect">
+            <a:avLst>
+              <a:gd name="adj" fmla="val 5581"/>
+            </a:avLst>
+          </a:prstGeom>
+          <a:solidFill>
+            <a:schemeClr val="bg2"/>
+          </a:solidFill>
+          <a:ln w="9525">
+            <a:solidFill>
+              <a:srgbClr val="C4CBD8"/>
+            </a:solidFill>
+            <a:prstDash val="solid"/>
+          </a:ln>
+        </p:spPr>
+      </p:sp>
+      <p:sp>
+        <p:nvSpPr>
+          <p:cNvPr id="36" name="Card label"/>
+          <p:cNvSpPr txBox="1"/>
+          <p:nvPr/>
+        </p:nvSpPr>
+        <p:spPr>
+          <a:xfrm>
+            <a:off x="731520" y="4989576"/>
+            <a:ext cx="1633667" cy="310896"/>
+          </a:xfrm>
+          <a:prstGeom prst="rect">
+            <a:avLst/>
+          </a:prstGeom>
+          <a:noFill/>
+          <a:ln/>
+        </p:spPr>
+        <p:txBody>
+          <a:bodyPr wrap="square" lIns="0" tIns="0" rIns="0" bIns="0" rtlCol="0" anchor="ctr"/>
+          <a:lstStyle/>
+          <a:p>
+            <a:pPr indent="0" marL="0">
+              <a:buNone/>
+            </a:pPr>
+            <a:r>
+              <a:rPr lang="en-US" sz="1300" b="1" dirty="0">
+                <a:solidFill>
+                  <a:schemeClr val="accent1"/>
+                </a:solidFill>
+              </a:rPr>
+              <a:t>AXIOM Lab 2.1</a:t>
+            </a:r>
+            <a:endParaRPr lang="en-US" sz="1300" dirty="0"/>
+          </a:p>
+        </p:txBody>
+      </p:sp>
+      <p:sp>
+        <p:nvSpPr>
+          <p:cNvPr id="37" name="Card head"/>
+          <p:cNvSpPr txBox="1"/>
+          <p:nvPr/>
+        </p:nvSpPr>
+        <p:spPr>
+          <a:xfrm>
+            <a:off x="731520" y="5318760"/>
+            <a:ext cx="1633667" cy="652272"/>
           </a:xfrm>
           <a:prstGeom prst="rect">
             <a:avLst/>

</xml_diff>